<commit_message>
Update customer pitch deck with visual structured layout and cards
</commit_message>
<xml_diff>
--- a/docs/Presentasi_PLTS_Customer.pptx
+++ b/docs/Presentasi_PLTS_Customer.pptx
@@ -12,7 +12,6 @@
     <p:sldId id="260" r:id="rId11"/>
     <p:sldId id="261" r:id="rId12"/>
     <p:sldId id="262" r:id="rId13"/>
-    <p:sldId id="263" r:id="rId14"/>
   </p:sldIdLst>
   <p:sldSz cx="9144000" cy="5143500" type="screen4x3"/>
   <p:notesSz cx="6858000" cy="9144000"/>
@@ -3103,8 +3102,8 @@
         </p:nvSpPr>
         <p:spPr>
           <a:xfrm>
-            <a:off x="731520" y="548640"/>
-            <a:ext cx="7680960" cy="731520"/>
+            <a:off x="731520" y="1097280"/>
+            <a:ext cx="7680960" cy="2926080"/>
           </a:xfrm>
           <a:prstGeom prst="rect">
             <a:avLst/>
@@ -3118,82 +3117,44 @@
           <a:lstStyle/>
           <a:p>
             <a:pPr>
-              <a:defRPr sz="2200" b="1">
-                <a:solidFill>
-                  <a:srgbClr val="0F172A"/>
+              <a:spcAft>
+                <a:spcPts val="1000"/>
+              </a:spcAft>
+              <a:defRPr sz="1200" b="1">
+                <a:solidFill>
+                  <a:srgbClr val="EA580C"/>
                 </a:solidFill>
               </a:defRPr>
             </a:pPr>
             <a:r>
-              <a:t>SOLUSI EFISIENSI ENERGI PLTS INDUSTRI</a:t>
-            </a:r>
-          </a:p>
-        </p:txBody>
-      </p:sp>
-      <p:sp>
-        <p:nvSpPr>
-          <p:cNvPr id="3" name="TextBox 2"/>
-          <p:cNvSpPr txBox="1"/>
-          <p:nvPr/>
-        </p:nvSpPr>
-        <p:spPr>
-          <a:xfrm>
-            <a:off x="731520" y="1371600"/>
-            <a:ext cx="7680960" cy="3200400"/>
-          </a:xfrm>
-          <a:prstGeom prst="rect">
-            <a:avLst/>
-          </a:prstGeom>
-          <a:noFill/>
-        </p:spPr>
-        <p:txBody>
-          <a:bodyPr wrap="square">
-            <a:spAutoFit/>
-          </a:bodyPr>
-          <a:lstStyle/>
+              <a:t>PITCH DECK EKSLUSIF CUSTOMER</a:t>
+            </a:r>
+          </a:p>
           <a:p>
             <a:pPr>
               <a:spcAft>
-                <a:spcPts val="1400"/>
+                <a:spcPts val="1200"/>
               </a:spcAft>
-              <a:defRPr sz="1500">
-                <a:solidFill>
-                  <a:srgbClr val="334155"/>
+              <a:defRPr sz="2800" b="1">
+                <a:solidFill>
+                  <a:srgbClr val="0F172A"/>
                 </a:solidFill>
               </a:defRPr>
             </a:pPr>
             <a:r>
-              <a:t>• Solusi Energi Terbarukan Berbasis Engineering Presisi</a:t>
+              <a:t>SOLUSI ENERGI TERBARU PLTS INDUSTRI</a:t>
             </a:r>
           </a:p>
           <a:p>
             <a:pPr>
-              <a:spcAft>
-                <a:spcPts val="1400"/>
-              </a:spcAft>
-              <a:defRPr sz="1500">
-                <a:solidFill>
-                  <a:srgbClr val="334155"/>
+              <a:defRPr sz="1600">
+                <a:solidFill>
+                  <a:srgbClr val="475569"/>
                 </a:solidFill>
               </a:defRPr>
             </a:pPr>
             <a:r>
-              <a:t>• Pangkas OPEX Listrik hingga 40-70% dengan Keandalan 25 Tahun</a:t>
-            </a:r>
-          </a:p>
-          <a:p>
-            <a:pPr>
-              <a:spcAft>
-                <a:spcPts val="1400"/>
-              </a:spcAft>
-              <a:defRPr sz="1500">
-                <a:solidFill>
-                  <a:srgbClr val="334155"/>
-                </a:solidFill>
-              </a:defRPr>
-            </a:pPr>
-            <a:r>
-              <a:t>• Disusun oleh: Tim Engineering &amp; Konsultan Energi</a:t>
+              <a:t>Transformasi Efisiensi Biaya Operasional Listrik &amp; Dekarbonisasi Perusahaan</a:t>
             </a:r>
           </a:p>
         </p:txBody>
@@ -3224,8 +3185,8 @@
         </p:nvSpPr>
         <p:spPr>
           <a:xfrm>
-            <a:off x="731520" y="548640"/>
-            <a:ext cx="7680960" cy="731520"/>
+            <a:off x="731520" y="457200"/>
+            <a:ext cx="7680960" cy="914400"/>
           </a:xfrm>
           <a:prstGeom prst="rect">
             <a:avLst/>
@@ -3239,28 +3200,131 @@
           <a:lstStyle/>
           <a:p>
             <a:pPr>
-              <a:defRPr sz="2200" b="1">
+              <a:defRPr sz="2000" b="1">
                 <a:solidFill>
                   <a:srgbClr val="0F172A"/>
                 </a:solidFill>
               </a:defRPr>
             </a:pPr>
             <a:r>
-              <a:t>TANTANGAN OPERASIONAL &amp; ENERGI</a:t>
-            </a:r>
-          </a:p>
-        </p:txBody>
-      </p:sp>
-      <p:sp>
-        <p:nvSpPr>
-          <p:cNvPr id="3" name="TextBox 2"/>
+              <a:t>TANTANGAN BIAYA ENERGI SAAT INI</a:t>
+            </a:r>
+          </a:p>
+          <a:p>
+            <a:pPr>
+              <a:spcBef>
+                <a:spcPts val="400"/>
+              </a:spcBef>
+              <a:defRPr sz="1300">
+                <a:solidFill>
+                  <a:srgbClr val="475569"/>
+                </a:solidFill>
+              </a:defRPr>
+            </a:pPr>
+            <a:r>
+              <a:t>Faktor pendorong perusahaan beralih ke pembangkitan surya mandiri</a:t>
+            </a:r>
+          </a:p>
+        </p:txBody>
+      </p:sp>
+      <p:sp>
+        <p:nvSpPr>
+          <p:cNvPr id="3" name="Rounded Rectangle 2"/>
+          <p:cNvSpPr/>
+          <p:nvPr/>
+        </p:nvSpPr>
+        <p:spPr>
+          <a:xfrm>
+            <a:off x="731520" y="1645920"/>
+            <a:ext cx="2414016" cy="3017520"/>
+          </a:xfrm>
+          <a:prstGeom prst="roundRect">
+            <a:avLst/>
+          </a:prstGeom>
+          <a:solidFill>
+            <a:srgbClr val="F8FAFC"/>
+          </a:solidFill>
+          <a:ln w="12700">
+            <a:solidFill>
+              <a:srgbClr val="E2E8F0"/>
+            </a:solidFill>
+          </a:ln>
+        </p:spPr>
+        <p:style>
+          <a:lnRef idx="1">
+            <a:schemeClr val="accent1"/>
+          </a:lnRef>
+          <a:fillRef idx="3">
+            <a:schemeClr val="accent1"/>
+          </a:fillRef>
+          <a:effectRef idx="2">
+            <a:schemeClr val="accent1"/>
+          </a:effectRef>
+          <a:fontRef idx="minor">
+            <a:schemeClr val="lt1"/>
+          </a:fontRef>
+        </p:style>
+        <p:txBody>
+          <a:bodyPr rtlCol="0" anchor="ctr"/>
+          <a:lstStyle/>
+          <a:p>
+            <a:pPr algn="ctr"/>
+          </a:p>
+        </p:txBody>
+      </p:sp>
+      <p:sp>
+        <p:nvSpPr>
+          <p:cNvPr id="4" name="Rectangle 3"/>
+          <p:cNvSpPr/>
+          <p:nvPr/>
+        </p:nvSpPr>
+        <p:spPr>
+          <a:xfrm>
+            <a:off x="731520" y="1645920"/>
+            <a:ext cx="2414016" cy="109728"/>
+          </a:xfrm>
+          <a:prstGeom prst="rect">
+            <a:avLst/>
+          </a:prstGeom>
+          <a:solidFill>
+            <a:srgbClr val="EA580C"/>
+          </a:solidFill>
+          <a:ln>
+            <a:noFill/>
+          </a:ln>
+        </p:spPr>
+        <p:style>
+          <a:lnRef idx="1">
+            <a:schemeClr val="accent1"/>
+          </a:lnRef>
+          <a:fillRef idx="3">
+            <a:schemeClr val="accent1"/>
+          </a:fillRef>
+          <a:effectRef idx="2">
+            <a:schemeClr val="accent1"/>
+          </a:effectRef>
+          <a:fontRef idx="minor">
+            <a:schemeClr val="lt1"/>
+          </a:fontRef>
+        </p:style>
+        <p:txBody>
+          <a:bodyPr rtlCol="0" anchor="ctr"/>
+          <a:lstStyle/>
+          <a:p>
+            <a:pPr algn="ctr"/>
+          </a:p>
+        </p:txBody>
+      </p:sp>
+      <p:sp>
+        <p:nvSpPr>
+          <p:cNvPr id="5" name="TextBox 4"/>
           <p:cNvSpPr txBox="1"/>
           <p:nvPr/>
         </p:nvSpPr>
         <p:spPr>
           <a:xfrm>
-            <a:off x="731520" y="1371600"/>
-            <a:ext cx="7680960" cy="3200400"/>
+            <a:off x="868680" y="1874520"/>
+            <a:ext cx="2139696" cy="2651760"/>
           </a:xfrm>
           <a:prstGeom prst="rect">
             <a:avLst/>
@@ -3275,46 +3339,304 @@
           <a:p>
             <a:pPr>
               <a:spcAft>
-                <a:spcPts val="1400"/>
+                <a:spcPts val="800"/>
               </a:spcAft>
-              <a:defRPr sz="1500">
-                <a:solidFill>
-                  <a:srgbClr val="334155"/>
+              <a:defRPr sz="1400" b="1">
+                <a:solidFill>
+                  <a:srgbClr val="0F172A"/>
                 </a:solidFill>
               </a:defRPr>
             </a:pPr>
             <a:r>
-              <a:t>• Kenaikan tarif dasar listrik industri dan risiko penalti beban puncak</a:t>
-            </a:r>
-          </a:p>
+              <a:t>Kenaikan TDL Industri</a:t>
+            </a:r>
+          </a:p>
+          <a:p>
+            <a:pPr>
+              <a:defRPr sz="1200">
+                <a:solidFill>
+                  <a:srgbClr val="475569"/>
+                </a:solidFill>
+              </a:defRPr>
+            </a:pPr>
+            <a:r>
+              <a:t>Tarif listrik grid komersial terus merangkak naik tiap tahun, membebani struktur OPEX bulanan.</a:t>
+            </a:r>
+          </a:p>
+        </p:txBody>
+      </p:sp>
+      <p:sp>
+        <p:nvSpPr>
+          <p:cNvPr id="6" name="Rounded Rectangle 5"/>
+          <p:cNvSpPr/>
+          <p:nvPr/>
+        </p:nvSpPr>
+        <p:spPr>
+          <a:xfrm>
+            <a:off x="3364991" y="1645920"/>
+            <a:ext cx="2414016" cy="3017520"/>
+          </a:xfrm>
+          <a:prstGeom prst="roundRect">
+            <a:avLst/>
+          </a:prstGeom>
+          <a:solidFill>
+            <a:srgbClr val="F8FAFC"/>
+          </a:solidFill>
+          <a:ln w="12700">
+            <a:solidFill>
+              <a:srgbClr val="E2E8F0"/>
+            </a:solidFill>
+          </a:ln>
+        </p:spPr>
+        <p:style>
+          <a:lnRef idx="1">
+            <a:schemeClr val="accent1"/>
+          </a:lnRef>
+          <a:fillRef idx="3">
+            <a:schemeClr val="accent1"/>
+          </a:fillRef>
+          <a:effectRef idx="2">
+            <a:schemeClr val="accent1"/>
+          </a:effectRef>
+          <a:fontRef idx="minor">
+            <a:schemeClr val="lt1"/>
+          </a:fontRef>
+        </p:style>
+        <p:txBody>
+          <a:bodyPr rtlCol="0" anchor="ctr"/>
+          <a:lstStyle/>
+          <a:p>
+            <a:pPr algn="ctr"/>
+          </a:p>
+        </p:txBody>
+      </p:sp>
+      <p:sp>
+        <p:nvSpPr>
+          <p:cNvPr id="7" name="Rectangle 6"/>
+          <p:cNvSpPr/>
+          <p:nvPr/>
+        </p:nvSpPr>
+        <p:spPr>
+          <a:xfrm>
+            <a:off x="3364991" y="1645920"/>
+            <a:ext cx="2414016" cy="109728"/>
+          </a:xfrm>
+          <a:prstGeom prst="rect">
+            <a:avLst/>
+          </a:prstGeom>
+          <a:solidFill>
+            <a:srgbClr val="EA580C"/>
+          </a:solidFill>
+          <a:ln>
+            <a:noFill/>
+          </a:ln>
+        </p:spPr>
+        <p:style>
+          <a:lnRef idx="1">
+            <a:schemeClr val="accent1"/>
+          </a:lnRef>
+          <a:fillRef idx="3">
+            <a:schemeClr val="accent1"/>
+          </a:fillRef>
+          <a:effectRef idx="2">
+            <a:schemeClr val="accent1"/>
+          </a:effectRef>
+          <a:fontRef idx="minor">
+            <a:schemeClr val="lt1"/>
+          </a:fontRef>
+        </p:style>
+        <p:txBody>
+          <a:bodyPr rtlCol="0" anchor="ctr"/>
+          <a:lstStyle/>
+          <a:p>
+            <a:pPr algn="ctr"/>
+          </a:p>
+        </p:txBody>
+      </p:sp>
+      <p:sp>
+        <p:nvSpPr>
+          <p:cNvPr id="8" name="TextBox 7"/>
+          <p:cNvSpPr txBox="1"/>
+          <p:nvPr/>
+        </p:nvSpPr>
+        <p:spPr>
+          <a:xfrm>
+            <a:off x="3502151" y="1874520"/>
+            <a:ext cx="2139696" cy="2651760"/>
+          </a:xfrm>
+          <a:prstGeom prst="rect">
+            <a:avLst/>
+          </a:prstGeom>
+          <a:noFill/>
+        </p:spPr>
+        <p:txBody>
+          <a:bodyPr wrap="square">
+            <a:spAutoFit/>
+          </a:bodyPr>
+          <a:lstStyle/>
           <a:p>
             <a:pPr>
               <a:spcAft>
-                <a:spcPts val="1400"/>
+                <a:spcPts val="800"/>
               </a:spcAft>
-              <a:defRPr sz="1500">
-                <a:solidFill>
-                  <a:srgbClr val="334155"/>
+              <a:defRPr sz="1400" b="1">
+                <a:solidFill>
+                  <a:srgbClr val="0F172A"/>
                 </a:solidFill>
               </a:defRPr>
             </a:pPr>
             <a:r>
-              <a:t>• Tuntutan efisiensi biaya operasional (OPEX) dan target ESG / Net Zero Emission</a:t>
-            </a:r>
-          </a:p>
+              <a:t>Penalti Beban Puncak</a:t>
+            </a:r>
+          </a:p>
+          <a:p>
+            <a:pPr>
+              <a:defRPr sz="1200">
+                <a:solidFill>
+                  <a:srgbClr val="475569"/>
+                </a:solidFill>
+              </a:defRPr>
+            </a:pPr>
+            <a:r>
+              <a:t>Lonjakan konsumsi listrik di jam siang hari sering berujung pada penalti kelebihan beban.</a:t>
+            </a:r>
+          </a:p>
+        </p:txBody>
+      </p:sp>
+      <p:sp>
+        <p:nvSpPr>
+          <p:cNvPr id="9" name="Rounded Rectangle 8"/>
+          <p:cNvSpPr/>
+          <p:nvPr/>
+        </p:nvSpPr>
+        <p:spPr>
+          <a:xfrm>
+            <a:off x="5998464" y="1645920"/>
+            <a:ext cx="2414016" cy="3017520"/>
+          </a:xfrm>
+          <a:prstGeom prst="roundRect">
+            <a:avLst/>
+          </a:prstGeom>
+          <a:solidFill>
+            <a:srgbClr val="F8FAFC"/>
+          </a:solidFill>
+          <a:ln w="12700">
+            <a:solidFill>
+              <a:srgbClr val="E2E8F0"/>
+            </a:solidFill>
+          </a:ln>
+        </p:spPr>
+        <p:style>
+          <a:lnRef idx="1">
+            <a:schemeClr val="accent1"/>
+          </a:lnRef>
+          <a:fillRef idx="3">
+            <a:schemeClr val="accent1"/>
+          </a:fillRef>
+          <a:effectRef idx="2">
+            <a:schemeClr val="accent1"/>
+          </a:effectRef>
+          <a:fontRef idx="minor">
+            <a:schemeClr val="lt1"/>
+          </a:fontRef>
+        </p:style>
+        <p:txBody>
+          <a:bodyPr rtlCol="0" anchor="ctr"/>
+          <a:lstStyle/>
+          <a:p>
+            <a:pPr algn="ctr"/>
+          </a:p>
+        </p:txBody>
+      </p:sp>
+      <p:sp>
+        <p:nvSpPr>
+          <p:cNvPr id="10" name="Rectangle 9"/>
+          <p:cNvSpPr/>
+          <p:nvPr/>
+        </p:nvSpPr>
+        <p:spPr>
+          <a:xfrm>
+            <a:off x="5998464" y="1645920"/>
+            <a:ext cx="2414016" cy="109728"/>
+          </a:xfrm>
+          <a:prstGeom prst="rect">
+            <a:avLst/>
+          </a:prstGeom>
+          <a:solidFill>
+            <a:srgbClr val="EA580C"/>
+          </a:solidFill>
+          <a:ln>
+            <a:noFill/>
+          </a:ln>
+        </p:spPr>
+        <p:style>
+          <a:lnRef idx="1">
+            <a:schemeClr val="accent1"/>
+          </a:lnRef>
+          <a:fillRef idx="3">
+            <a:schemeClr val="accent1"/>
+          </a:fillRef>
+          <a:effectRef idx="2">
+            <a:schemeClr val="accent1"/>
+          </a:effectRef>
+          <a:fontRef idx="minor">
+            <a:schemeClr val="lt1"/>
+          </a:fontRef>
+        </p:style>
+        <p:txBody>
+          <a:bodyPr rtlCol="0" anchor="ctr"/>
+          <a:lstStyle/>
+          <a:p>
+            <a:pPr algn="ctr"/>
+          </a:p>
+        </p:txBody>
+      </p:sp>
+      <p:sp>
+        <p:nvSpPr>
+          <p:cNvPr id="11" name="TextBox 10"/>
+          <p:cNvSpPr txBox="1"/>
+          <p:nvPr/>
+        </p:nvSpPr>
+        <p:spPr>
+          <a:xfrm>
+            <a:off x="6135624" y="1874520"/>
+            <a:ext cx="2139696" cy="2651760"/>
+          </a:xfrm>
+          <a:prstGeom prst="rect">
+            <a:avLst/>
+          </a:prstGeom>
+          <a:noFill/>
+        </p:spPr>
+        <p:txBody>
+          <a:bodyPr wrap="square">
+            <a:spAutoFit/>
+          </a:bodyPr>
+          <a:lstStyle/>
           <a:p>
             <a:pPr>
               <a:spcAft>
-                <a:spcPts val="1400"/>
+                <a:spcPts val="800"/>
               </a:spcAft>
-              <a:defRPr sz="1500">
-                <a:solidFill>
-                  <a:srgbClr val="334155"/>
+              <a:defRPr sz="1400" b="1">
+                <a:solidFill>
+                  <a:srgbClr val="0F172A"/>
                 </a:solidFill>
               </a:defRPr>
             </a:pPr>
             <a:r>
-              <a:t>• Kekhawatiran penurunan produksi akibat perencanaan sizing sistem yang kurang akurat</a:t>
+              <a:t>Tuntutan ESG / Net-Zero</a:t>
+            </a:r>
+          </a:p>
+          <a:p>
+            <a:pPr>
+              <a:defRPr sz="1200">
+                <a:solidFill>
+                  <a:srgbClr val="475569"/>
+                </a:solidFill>
+              </a:defRPr>
+            </a:pPr>
+            <a:r>
+              <a:t>Komitmen korporasi global terhadap dekarbonisasi rantai pasok dan efisiensi hijau.</a:t>
             </a:r>
           </a:p>
         </p:txBody>
@@ -3345,8 +3667,8 @@
         </p:nvSpPr>
         <p:spPr>
           <a:xfrm>
-            <a:off x="731520" y="548640"/>
-            <a:ext cx="7680960" cy="731520"/>
+            <a:off x="731520" y="457200"/>
+            <a:ext cx="7680960" cy="914400"/>
           </a:xfrm>
           <a:prstGeom prst="rect">
             <a:avLst/>
@@ -3360,28 +3682,131 @@
           <a:lstStyle/>
           <a:p>
             <a:pPr>
-              <a:defRPr sz="2200" b="1">
+              <a:defRPr sz="2000" b="1">
                 <a:solidFill>
                   <a:srgbClr val="0F172A"/>
                 </a:solidFill>
               </a:defRPr>
             </a:pPr>
             <a:r>
-              <a:t>SOLUSI &amp; NILAI TAMBAH KAMI</a:t>
-            </a:r>
-          </a:p>
-        </p:txBody>
-      </p:sp>
-      <p:sp>
-        <p:nvSpPr>
-          <p:cNvPr id="3" name="TextBox 2"/>
+              <a:t>SOLUSI TERINTEGRASI KAMI</a:t>
+            </a:r>
+          </a:p>
+          <a:p>
+            <a:pPr>
+              <a:spcBef>
+                <a:spcPts val="400"/>
+              </a:spcBef>
+              <a:defRPr sz="1300">
+                <a:solidFill>
+                  <a:srgbClr val="475569"/>
+                </a:solidFill>
+              </a:defRPr>
+            </a:pPr>
+            <a:r>
+              <a:t>Sistem pembangkitan surya handal dengan pendekatan engineering presisi</a:t>
+            </a:r>
+          </a:p>
+        </p:txBody>
+      </p:sp>
+      <p:sp>
+        <p:nvSpPr>
+          <p:cNvPr id="3" name="Rounded Rectangle 2"/>
+          <p:cNvSpPr/>
+          <p:nvPr/>
+        </p:nvSpPr>
+        <p:spPr>
+          <a:xfrm>
+            <a:off x="731520" y="1645920"/>
+            <a:ext cx="2414016" cy="3017520"/>
+          </a:xfrm>
+          <a:prstGeom prst="roundRect">
+            <a:avLst/>
+          </a:prstGeom>
+          <a:solidFill>
+            <a:srgbClr val="F8FAFC"/>
+          </a:solidFill>
+          <a:ln w="12700">
+            <a:solidFill>
+              <a:srgbClr val="E2E8F0"/>
+            </a:solidFill>
+          </a:ln>
+        </p:spPr>
+        <p:style>
+          <a:lnRef idx="1">
+            <a:schemeClr val="accent1"/>
+          </a:lnRef>
+          <a:fillRef idx="3">
+            <a:schemeClr val="accent1"/>
+          </a:fillRef>
+          <a:effectRef idx="2">
+            <a:schemeClr val="accent1"/>
+          </a:effectRef>
+          <a:fontRef idx="minor">
+            <a:schemeClr val="lt1"/>
+          </a:fontRef>
+        </p:style>
+        <p:txBody>
+          <a:bodyPr rtlCol="0" anchor="ctr"/>
+          <a:lstStyle/>
+          <a:p>
+            <a:pPr algn="ctr"/>
+          </a:p>
+        </p:txBody>
+      </p:sp>
+      <p:sp>
+        <p:nvSpPr>
+          <p:cNvPr id="4" name="Rectangle 3"/>
+          <p:cNvSpPr/>
+          <p:nvPr/>
+        </p:nvSpPr>
+        <p:spPr>
+          <a:xfrm>
+            <a:off x="731520" y="1645920"/>
+            <a:ext cx="2414016" cy="109728"/>
+          </a:xfrm>
+          <a:prstGeom prst="rect">
+            <a:avLst/>
+          </a:prstGeom>
+          <a:solidFill>
+            <a:srgbClr val="EA580C"/>
+          </a:solidFill>
+          <a:ln>
+            <a:noFill/>
+          </a:ln>
+        </p:spPr>
+        <p:style>
+          <a:lnRef idx="1">
+            <a:schemeClr val="accent1"/>
+          </a:lnRef>
+          <a:fillRef idx="3">
+            <a:schemeClr val="accent1"/>
+          </a:fillRef>
+          <a:effectRef idx="2">
+            <a:schemeClr val="accent1"/>
+          </a:effectRef>
+          <a:fontRef idx="minor">
+            <a:schemeClr val="lt1"/>
+          </a:fontRef>
+        </p:style>
+        <p:txBody>
+          <a:bodyPr rtlCol="0" anchor="ctr"/>
+          <a:lstStyle/>
+          <a:p>
+            <a:pPr algn="ctr"/>
+          </a:p>
+        </p:txBody>
+      </p:sp>
+      <p:sp>
+        <p:nvSpPr>
+          <p:cNvPr id="5" name="TextBox 4"/>
           <p:cNvSpPr txBox="1"/>
           <p:nvPr/>
         </p:nvSpPr>
         <p:spPr>
           <a:xfrm>
-            <a:off x="731520" y="1371600"/>
-            <a:ext cx="7680960" cy="3200400"/>
+            <a:off x="868680" y="1874520"/>
+            <a:ext cx="2139696" cy="2651760"/>
           </a:xfrm>
           <a:prstGeom prst="rect">
             <a:avLst/>
@@ -3396,46 +3821,304 @@
           <a:p>
             <a:pPr>
               <a:spcAft>
-                <a:spcPts val="1400"/>
+                <a:spcPts val="800"/>
               </a:spcAft>
-              <a:defRPr sz="1500">
-                <a:solidFill>
-                  <a:srgbClr val="334155"/>
+              <a:defRPr sz="1400" b="1">
+                <a:solidFill>
+                  <a:srgbClr val="0F172A"/>
                 </a:solidFill>
               </a:defRPr>
             </a:pPr>
             <a:r>
-              <a:t>• Perancangan sistem PLTS terintegrasi (On-Grid / Hybrid / Off-Grid) custom</a:t>
-            </a:r>
-          </a:p>
+              <a:t>Topologi Fleksibel</a:t>
+            </a:r>
+          </a:p>
+          <a:p>
+            <a:pPr>
+              <a:defRPr sz="1200">
+                <a:solidFill>
+                  <a:srgbClr val="475569"/>
+                </a:solidFill>
+              </a:defRPr>
+            </a:pPr>
+            <a:r>
+              <a:t>Desain On-Grid, Off-Grid, atau Hybrid sesuai profil beban dan kebutuhan suplai daya.</a:t>
+            </a:r>
+          </a:p>
+        </p:txBody>
+      </p:sp>
+      <p:sp>
+        <p:nvSpPr>
+          <p:cNvPr id="6" name="Rounded Rectangle 5"/>
+          <p:cNvSpPr/>
+          <p:nvPr/>
+        </p:nvSpPr>
+        <p:spPr>
+          <a:xfrm>
+            <a:off x="3364991" y="1645920"/>
+            <a:ext cx="2414016" cy="3017520"/>
+          </a:xfrm>
+          <a:prstGeom prst="roundRect">
+            <a:avLst/>
+          </a:prstGeom>
+          <a:solidFill>
+            <a:srgbClr val="F8FAFC"/>
+          </a:solidFill>
+          <a:ln w="12700">
+            <a:solidFill>
+              <a:srgbClr val="E2E8F0"/>
+            </a:solidFill>
+          </a:ln>
+        </p:spPr>
+        <p:style>
+          <a:lnRef idx="1">
+            <a:schemeClr val="accent1"/>
+          </a:lnRef>
+          <a:fillRef idx="3">
+            <a:schemeClr val="accent1"/>
+          </a:fillRef>
+          <a:effectRef idx="2">
+            <a:schemeClr val="accent1"/>
+          </a:effectRef>
+          <a:fontRef idx="minor">
+            <a:schemeClr val="lt1"/>
+          </a:fontRef>
+        </p:style>
+        <p:txBody>
+          <a:bodyPr rtlCol="0" anchor="ctr"/>
+          <a:lstStyle/>
+          <a:p>
+            <a:pPr algn="ctr"/>
+          </a:p>
+        </p:txBody>
+      </p:sp>
+      <p:sp>
+        <p:nvSpPr>
+          <p:cNvPr id="7" name="Rectangle 6"/>
+          <p:cNvSpPr/>
+          <p:nvPr/>
+        </p:nvSpPr>
+        <p:spPr>
+          <a:xfrm>
+            <a:off x="3364991" y="1645920"/>
+            <a:ext cx="2414016" cy="109728"/>
+          </a:xfrm>
+          <a:prstGeom prst="rect">
+            <a:avLst/>
+          </a:prstGeom>
+          <a:solidFill>
+            <a:srgbClr val="EA580C"/>
+          </a:solidFill>
+          <a:ln>
+            <a:noFill/>
+          </a:ln>
+        </p:spPr>
+        <p:style>
+          <a:lnRef idx="1">
+            <a:schemeClr val="accent1"/>
+          </a:lnRef>
+          <a:fillRef idx="3">
+            <a:schemeClr val="accent1"/>
+          </a:fillRef>
+          <a:effectRef idx="2">
+            <a:schemeClr val="accent1"/>
+          </a:effectRef>
+          <a:fontRef idx="minor">
+            <a:schemeClr val="lt1"/>
+          </a:fontRef>
+        </p:style>
+        <p:txBody>
+          <a:bodyPr rtlCol="0" anchor="ctr"/>
+          <a:lstStyle/>
+          <a:p>
+            <a:pPr algn="ctr"/>
+          </a:p>
+        </p:txBody>
+      </p:sp>
+      <p:sp>
+        <p:nvSpPr>
+          <p:cNvPr id="8" name="TextBox 7"/>
+          <p:cNvSpPr txBox="1"/>
+          <p:nvPr/>
+        </p:nvSpPr>
+        <p:spPr>
+          <a:xfrm>
+            <a:off x="3502151" y="1874520"/>
+            <a:ext cx="2139696" cy="2651760"/>
+          </a:xfrm>
+          <a:prstGeom prst="rect">
+            <a:avLst/>
+          </a:prstGeom>
+          <a:noFill/>
+        </p:spPr>
+        <p:txBody>
+          <a:bodyPr wrap="square">
+            <a:spAutoFit/>
+          </a:bodyPr>
+          <a:lstStyle/>
           <a:p>
             <a:pPr>
               <a:spcAft>
-                <a:spcPts val="1400"/>
+                <a:spcPts val="800"/>
               </a:spcAft>
-              <a:defRPr sz="1500">
-                <a:solidFill>
-                  <a:srgbClr val="334155"/>
+              <a:defRPr sz="1400" b="1">
+                <a:solidFill>
+                  <a:srgbClr val="0F172A"/>
                 </a:solidFill>
               </a:defRPr>
             </a:pPr>
             <a:r>
-              <a:t>• Simulasi data per jam (Hourly Dispatch Simulation) berbasis profil beban riil</a:t>
-            </a:r>
-          </a:p>
+              <a:t>Simulasi Data Jam-an</a:t>
+            </a:r>
+          </a:p>
+          <a:p>
+            <a:pPr>
+              <a:defRPr sz="1200">
+                <a:solidFill>
+                  <a:srgbClr val="475569"/>
+                </a:solidFill>
+              </a:defRPr>
+            </a:pPr>
+            <a:r>
+              <a:t>Perhitungan akurat berbasis profil beban riil dan radiasi matahari lokal (NASA/Ninja).</a:t>
+            </a:r>
+          </a:p>
+        </p:txBody>
+      </p:sp>
+      <p:sp>
+        <p:nvSpPr>
+          <p:cNvPr id="9" name="Rounded Rectangle 8"/>
+          <p:cNvSpPr/>
+          <p:nvPr/>
+        </p:nvSpPr>
+        <p:spPr>
+          <a:xfrm>
+            <a:off x="5998464" y="1645920"/>
+            <a:ext cx="2414016" cy="3017520"/>
+          </a:xfrm>
+          <a:prstGeom prst="roundRect">
+            <a:avLst/>
+          </a:prstGeom>
+          <a:solidFill>
+            <a:srgbClr val="F8FAFC"/>
+          </a:solidFill>
+          <a:ln w="12700">
+            <a:solidFill>
+              <a:srgbClr val="E2E8F0"/>
+            </a:solidFill>
+          </a:ln>
+        </p:spPr>
+        <p:style>
+          <a:lnRef idx="1">
+            <a:schemeClr val="accent1"/>
+          </a:lnRef>
+          <a:fillRef idx="3">
+            <a:schemeClr val="accent1"/>
+          </a:fillRef>
+          <a:effectRef idx="2">
+            <a:schemeClr val="accent1"/>
+          </a:effectRef>
+          <a:fontRef idx="minor">
+            <a:schemeClr val="lt1"/>
+          </a:fontRef>
+        </p:style>
+        <p:txBody>
+          <a:bodyPr rtlCol="0" anchor="ctr"/>
+          <a:lstStyle/>
+          <a:p>
+            <a:pPr algn="ctr"/>
+          </a:p>
+        </p:txBody>
+      </p:sp>
+      <p:sp>
+        <p:nvSpPr>
+          <p:cNvPr id="10" name="Rectangle 9"/>
+          <p:cNvSpPr/>
+          <p:nvPr/>
+        </p:nvSpPr>
+        <p:spPr>
+          <a:xfrm>
+            <a:off x="5998464" y="1645920"/>
+            <a:ext cx="2414016" cy="109728"/>
+          </a:xfrm>
+          <a:prstGeom prst="rect">
+            <a:avLst/>
+          </a:prstGeom>
+          <a:solidFill>
+            <a:srgbClr val="EA580C"/>
+          </a:solidFill>
+          <a:ln>
+            <a:noFill/>
+          </a:ln>
+        </p:spPr>
+        <p:style>
+          <a:lnRef idx="1">
+            <a:schemeClr val="accent1"/>
+          </a:lnRef>
+          <a:fillRef idx="3">
+            <a:schemeClr val="accent1"/>
+          </a:fillRef>
+          <a:effectRef idx="2">
+            <a:schemeClr val="accent1"/>
+          </a:effectRef>
+          <a:fontRef idx="minor">
+            <a:schemeClr val="lt1"/>
+          </a:fontRef>
+        </p:style>
+        <p:txBody>
+          <a:bodyPr rtlCol="0" anchor="ctr"/>
+          <a:lstStyle/>
+          <a:p>
+            <a:pPr algn="ctr"/>
+          </a:p>
+        </p:txBody>
+      </p:sp>
+      <p:sp>
+        <p:nvSpPr>
+          <p:cNvPr id="11" name="TextBox 10"/>
+          <p:cNvSpPr txBox="1"/>
+          <p:nvPr/>
+        </p:nvSpPr>
+        <p:spPr>
+          <a:xfrm>
+            <a:off x="6135624" y="1874520"/>
+            <a:ext cx="2139696" cy="2651760"/>
+          </a:xfrm>
+          <a:prstGeom prst="rect">
+            <a:avLst/>
+          </a:prstGeom>
+          <a:noFill/>
+        </p:spPr>
+        <p:txBody>
+          <a:bodyPr wrap="square">
+            <a:spAutoFit/>
+          </a:bodyPr>
+          <a:lstStyle/>
           <a:p>
             <a:pPr>
               <a:spcAft>
-                <a:spcPts val="1400"/>
+                <a:spcPts val="800"/>
               </a:spcAft>
-              <a:defRPr sz="1500">
-                <a:solidFill>
-                  <a:srgbClr val="334155"/>
+              <a:defRPr sz="1400" b="1">
+                <a:solidFill>
+                  <a:srgbClr val="0F172A"/>
                 </a:solidFill>
               </a:defRPr>
             </a:pPr>
             <a:r>
-              <a:t>• Komponen Tier-1 berstandar internasional dengan garansi performa 25 tahun</a:t>
+              <a:t>Garansi Performa 25 Tahun</a:t>
+            </a:r>
+          </a:p>
+          <a:p>
+            <a:pPr>
+              <a:defRPr sz="1200">
+                <a:solidFill>
+                  <a:srgbClr val="475569"/>
+                </a:solidFill>
+              </a:defRPr>
+            </a:pPr>
+            <a:r>
+              <a:t>Komponen Tier-1 berstandar internasional dengan tingkat degradasi minimal.</a:t>
             </a:r>
           </a:p>
         </p:txBody>
@@ -3466,8 +4149,8 @@
         </p:nvSpPr>
         <p:spPr>
           <a:xfrm>
-            <a:off x="731520" y="548640"/>
-            <a:ext cx="7680960" cy="731520"/>
+            <a:off x="731520" y="457200"/>
+            <a:ext cx="7680960" cy="914400"/>
           </a:xfrm>
           <a:prstGeom prst="rect">
             <a:avLst/>
@@ -3481,7 +4164,7 @@
           <a:lstStyle/>
           <a:p>
             <a:pPr>
-              <a:defRPr sz="2200" b="1">
+              <a:defRPr sz="2000" b="1">
                 <a:solidFill>
                   <a:srgbClr val="0F172A"/>
                 </a:solidFill>
@@ -3491,18 +4174,121 @@
               <a:t>METODOLOGI &amp; SIZING PRESISI</a:t>
             </a:r>
           </a:p>
-        </p:txBody>
-      </p:sp>
-      <p:sp>
-        <p:nvSpPr>
-          <p:cNvPr id="3" name="TextBox 2"/>
+          <a:p>
+            <a:pPr>
+              <a:spcBef>
+                <a:spcPts val="400"/>
+              </a:spcBef>
+              <a:defRPr sz="1300">
+                <a:solidFill>
+                  <a:srgbClr val="475569"/>
+                </a:solidFill>
+              </a:defRPr>
+            </a:pPr>
+            <a:r>
+              <a:t>Menjamin performa pembangkitan optimal sepanjang masa pakai</a:t>
+            </a:r>
+          </a:p>
+        </p:txBody>
+      </p:sp>
+      <p:sp>
+        <p:nvSpPr>
+          <p:cNvPr id="3" name="Rounded Rectangle 2"/>
+          <p:cNvSpPr/>
+          <p:nvPr/>
+        </p:nvSpPr>
+        <p:spPr>
+          <a:xfrm>
+            <a:off x="731520" y="1645920"/>
+            <a:ext cx="3749039" cy="3017520"/>
+          </a:xfrm>
+          <a:prstGeom prst="roundRect">
+            <a:avLst/>
+          </a:prstGeom>
+          <a:solidFill>
+            <a:srgbClr val="F8FAFC"/>
+          </a:solidFill>
+          <a:ln>
+            <a:solidFill>
+              <a:srgbClr val="E2E8F0"/>
+            </a:solidFill>
+          </a:ln>
+        </p:spPr>
+        <p:style>
+          <a:lnRef idx="1">
+            <a:schemeClr val="accent1"/>
+          </a:lnRef>
+          <a:fillRef idx="3">
+            <a:schemeClr val="accent1"/>
+          </a:fillRef>
+          <a:effectRef idx="2">
+            <a:schemeClr val="accent1"/>
+          </a:effectRef>
+          <a:fontRef idx="minor">
+            <a:schemeClr val="lt1"/>
+          </a:fontRef>
+        </p:style>
+        <p:txBody>
+          <a:bodyPr rtlCol="0" anchor="ctr"/>
+          <a:lstStyle/>
+          <a:p>
+            <a:pPr algn="ctr"/>
+          </a:p>
+        </p:txBody>
+      </p:sp>
+      <p:sp>
+        <p:nvSpPr>
+          <p:cNvPr id="4" name="Rectangle 3"/>
+          <p:cNvSpPr/>
+          <p:nvPr/>
+        </p:nvSpPr>
+        <p:spPr>
+          <a:xfrm>
+            <a:off x="731520" y="1645920"/>
+            <a:ext cx="3749039" cy="109728"/>
+          </a:xfrm>
+          <a:prstGeom prst="rect">
+            <a:avLst/>
+          </a:prstGeom>
+          <a:solidFill>
+            <a:srgbClr val="0F172A"/>
+          </a:solidFill>
+          <a:ln>
+            <a:noFill/>
+          </a:ln>
+        </p:spPr>
+        <p:style>
+          <a:lnRef idx="1">
+            <a:schemeClr val="accent1"/>
+          </a:lnRef>
+          <a:fillRef idx="3">
+            <a:schemeClr val="accent1"/>
+          </a:fillRef>
+          <a:effectRef idx="2">
+            <a:schemeClr val="accent1"/>
+          </a:effectRef>
+          <a:fontRef idx="minor">
+            <a:schemeClr val="lt1"/>
+          </a:fontRef>
+        </p:style>
+        <p:txBody>
+          <a:bodyPr rtlCol="0" anchor="ctr"/>
+          <a:lstStyle/>
+          <a:p>
+            <a:pPr algn="ctr"/>
+          </a:p>
+        </p:txBody>
+      </p:sp>
+      <p:sp>
+        <p:nvSpPr>
+          <p:cNvPr id="5" name="TextBox 4"/>
           <p:cNvSpPr txBox="1"/>
           <p:nvPr/>
         </p:nvSpPr>
         <p:spPr>
           <a:xfrm>
-            <a:off x="731520" y="1371600"/>
-            <a:ext cx="7680960" cy="3200400"/>
+            <a:off x="914400" y="1874520"/>
+            <a:ext cx="3383279" cy="2651760"/>
           </a:xfrm>
           <a:prstGeom prst="rect">
             <a:avLst/>
@@ -3517,46 +4303,232 @@
           <a:p>
             <a:pPr>
               <a:spcAft>
-                <a:spcPts val="1400"/>
+                <a:spcPts val="1000"/>
               </a:spcAft>
-              <a:defRPr sz="1500">
-                <a:solidFill>
-                  <a:srgbClr val="334155"/>
+              <a:defRPr sz="1500" b="1">
+                <a:solidFill>
+                  <a:srgbClr val="0F172A"/>
                 </a:solidFill>
               </a:defRPr>
             </a:pPr>
             <a:r>
-              <a:t>• Audit radiasi surya lokasi berbasis satelit (Renewables.ninja / NASA SSE)</a:t>
+              <a:t>Audit &amp; Pemodelan Teknis</a:t>
             </a:r>
           </a:p>
           <a:p>
             <a:pPr>
               <a:spcAft>
-                <a:spcPts val="1400"/>
+                <a:spcPts val="600"/>
               </a:spcAft>
-              <a:defRPr sz="1500">
-                <a:solidFill>
-                  <a:srgbClr val="334155"/>
+              <a:defRPr sz="1300">
+                <a:solidFill>
+                  <a:srgbClr val="475569"/>
                 </a:solidFill>
               </a:defRPr>
             </a:pPr>
             <a:r>
-              <a:t>• Pencocokan presisi kurva beban harian dengan kapasitas pembangkitan</a:t>
+              <a:t>• Analisis profil beban 24 jam</a:t>
             </a:r>
           </a:p>
           <a:p>
             <a:pPr>
               <a:spcAft>
-                <a:spcPts val="1400"/>
+                <a:spcPts val="600"/>
               </a:spcAft>
-              <a:defRPr sz="1500">
-                <a:solidFill>
-                  <a:srgbClr val="334155"/>
+              <a:defRPr sz="1300">
+                <a:solidFill>
+                  <a:srgbClr val="475569"/>
                 </a:solidFill>
               </a:defRPr>
             </a:pPr>
             <a:r>
-              <a:t>• Optimasi batasan lahan atap dan kapasitas struktur beban (Roof Load Capacity)</a:t>
+              <a:t>• Survey radiasi &amp; suhu lokasi ekstrem</a:t>
+            </a:r>
+          </a:p>
+          <a:p>
+            <a:pPr>
+              <a:spcAft>
+                <a:spcPts val="600"/>
+              </a:spcAft>
+              <a:defRPr sz="1300">
+                <a:solidFill>
+                  <a:srgbClr val="475569"/>
+                </a:solidFill>
+              </a:defRPr>
+            </a:pPr>
+            <a:r>
+              <a:t>• Kalkulasi batas beban struktur atap</a:t>
+            </a:r>
+          </a:p>
+        </p:txBody>
+      </p:sp>
+      <p:sp>
+        <p:nvSpPr>
+          <p:cNvPr id="6" name="Rounded Rectangle 5"/>
+          <p:cNvSpPr/>
+          <p:nvPr/>
+        </p:nvSpPr>
+        <p:spPr>
+          <a:xfrm>
+            <a:off x="4709159" y="1645920"/>
+            <a:ext cx="3749039" cy="3017520"/>
+          </a:xfrm>
+          <a:prstGeom prst="roundRect">
+            <a:avLst/>
+          </a:prstGeom>
+          <a:solidFill>
+            <a:srgbClr val="F8FAFC"/>
+          </a:solidFill>
+          <a:ln>
+            <a:solidFill>
+              <a:srgbClr val="E2E8F0"/>
+            </a:solidFill>
+          </a:ln>
+        </p:spPr>
+        <p:style>
+          <a:lnRef idx="1">
+            <a:schemeClr val="accent1"/>
+          </a:lnRef>
+          <a:fillRef idx="3">
+            <a:schemeClr val="accent1"/>
+          </a:fillRef>
+          <a:effectRef idx="2">
+            <a:schemeClr val="accent1"/>
+          </a:effectRef>
+          <a:fontRef idx="minor">
+            <a:schemeClr val="lt1"/>
+          </a:fontRef>
+        </p:style>
+        <p:txBody>
+          <a:bodyPr rtlCol="0" anchor="ctr"/>
+          <a:lstStyle/>
+          <a:p>
+            <a:pPr algn="ctr"/>
+          </a:p>
+        </p:txBody>
+      </p:sp>
+      <p:sp>
+        <p:nvSpPr>
+          <p:cNvPr id="7" name="Rectangle 6"/>
+          <p:cNvSpPr/>
+          <p:nvPr/>
+        </p:nvSpPr>
+        <p:spPr>
+          <a:xfrm>
+            <a:off x="4709159" y="1645920"/>
+            <a:ext cx="3749039" cy="109728"/>
+          </a:xfrm>
+          <a:prstGeom prst="rect">
+            <a:avLst/>
+          </a:prstGeom>
+          <a:solidFill>
+            <a:srgbClr val="0F172A"/>
+          </a:solidFill>
+          <a:ln>
+            <a:noFill/>
+          </a:ln>
+        </p:spPr>
+        <p:style>
+          <a:lnRef idx="1">
+            <a:schemeClr val="accent1"/>
+          </a:lnRef>
+          <a:fillRef idx="3">
+            <a:schemeClr val="accent1"/>
+          </a:fillRef>
+          <a:effectRef idx="2">
+            <a:schemeClr val="accent1"/>
+          </a:effectRef>
+          <a:fontRef idx="minor">
+            <a:schemeClr val="lt1"/>
+          </a:fontRef>
+        </p:style>
+        <p:txBody>
+          <a:bodyPr rtlCol="0" anchor="ctr"/>
+          <a:lstStyle/>
+          <a:p>
+            <a:pPr algn="ctr"/>
+          </a:p>
+        </p:txBody>
+      </p:sp>
+      <p:sp>
+        <p:nvSpPr>
+          <p:cNvPr id="8" name="TextBox 7"/>
+          <p:cNvSpPr txBox="1"/>
+          <p:nvPr/>
+        </p:nvSpPr>
+        <p:spPr>
+          <a:xfrm>
+            <a:off x="4892039" y="1874520"/>
+            <a:ext cx="3383279" cy="2651760"/>
+          </a:xfrm>
+          <a:prstGeom prst="rect">
+            <a:avLst/>
+          </a:prstGeom>
+          <a:noFill/>
+        </p:spPr>
+        <p:txBody>
+          <a:bodyPr wrap="square">
+            <a:spAutoFit/>
+          </a:bodyPr>
+          <a:lstStyle/>
+          <a:p>
+            <a:pPr>
+              <a:spcAft>
+                <a:spcPts val="1000"/>
+              </a:spcAft>
+              <a:defRPr sz="1500" b="1">
+                <a:solidFill>
+                  <a:srgbClr val="0F172A"/>
+                </a:solidFill>
+              </a:defRPr>
+            </a:pPr>
+            <a:r>
+              <a:t>Keandalan Elektrikal</a:t>
+            </a:r>
+          </a:p>
+          <a:p>
+            <a:pPr>
+              <a:spcAft>
+                <a:spcPts val="600"/>
+              </a:spcAft>
+              <a:defRPr sz="1300">
+                <a:solidFill>
+                  <a:srgbClr val="475569"/>
+                </a:solidFill>
+              </a:defRPr>
+            </a:pPr>
+            <a:r>
+              <a:t>• Optimum Vmp pada rentang MPPT</a:t>
+            </a:r>
+          </a:p>
+          <a:p>
+            <a:pPr>
+              <a:spcAft>
+                <a:spcPts val="600"/>
+              </a:spcAft>
+              <a:defRPr sz="1300">
+                <a:solidFill>
+                  <a:srgbClr val="475569"/>
+                </a:solidFill>
+              </a:defRPr>
+            </a:pPr>
+            <a:r>
+              <a:t>• Proteksi tegangan Voc suhu dingin</a:t>
+            </a:r>
+          </a:p>
+          <a:p>
+            <a:pPr>
+              <a:spcAft>
+                <a:spcPts val="600"/>
+              </a:spcAft>
+              <a:defRPr sz="1300">
+                <a:solidFill>
+                  <a:srgbClr val="475569"/>
+                </a:solidFill>
+              </a:defRPr>
+            </a:pPr>
+            <a:r>
+              <a:t>• Kapasitas arus DC &amp; AC seimbang</a:t>
             </a:r>
           </a:p>
         </p:txBody>
@@ -3587,8 +4559,8 @@
         </p:nvSpPr>
         <p:spPr>
           <a:xfrm>
-            <a:off x="731520" y="548640"/>
-            <a:ext cx="7680960" cy="731520"/>
+            <a:off x="731520" y="457200"/>
+            <a:ext cx="7680960" cy="914400"/>
           </a:xfrm>
           <a:prstGeom prst="rect">
             <a:avLst/>
@@ -3602,28 +4574,131 @@
           <a:lstStyle/>
           <a:p>
             <a:pPr>
-              <a:defRPr sz="2200" b="1">
+              <a:defRPr sz="2000" b="1">
                 <a:solidFill>
                   <a:srgbClr val="0F172A"/>
                 </a:solidFill>
               </a:defRPr>
             </a:pPr>
             <a:r>
-              <a:t>KEANDALAN &amp; KEAMANAN ELEKTRIKAL</a:t>
-            </a:r>
-          </a:p>
-        </p:txBody>
-      </p:sp>
-      <p:sp>
-        <p:nvSpPr>
-          <p:cNvPr id="3" name="TextBox 2"/>
+              <a:t>KELAYAKAN &amp; PROYEKSI FINANSIAL</a:t>
+            </a:r>
+          </a:p>
+          <a:p>
+            <a:pPr>
+              <a:spcBef>
+                <a:spcPts val="400"/>
+              </a:spcBef>
+              <a:defRPr sz="1300">
+                <a:solidFill>
+                  <a:srgbClr val="475569"/>
+                </a:solidFill>
+              </a:defRPr>
+            </a:pPr>
+            <a:r>
+              <a:t>Keuntungan investasi jangka panjang dengan cashflow positif</a:t>
+            </a:r>
+          </a:p>
+        </p:txBody>
+      </p:sp>
+      <p:sp>
+        <p:nvSpPr>
+          <p:cNvPr id="3" name="Rounded Rectangle 2"/>
+          <p:cNvSpPr/>
+          <p:nvPr/>
+        </p:nvSpPr>
+        <p:spPr>
+          <a:xfrm>
+            <a:off x="731520" y="1828800"/>
+            <a:ext cx="1810512" cy="2651760"/>
+          </a:xfrm>
+          <a:prstGeom prst="roundRect">
+            <a:avLst/>
+          </a:prstGeom>
+          <a:solidFill>
+            <a:srgbClr val="F8FAFC"/>
+          </a:solidFill>
+          <a:ln>
+            <a:solidFill>
+              <a:srgbClr val="E2E8F0"/>
+            </a:solidFill>
+          </a:ln>
+        </p:spPr>
+        <p:style>
+          <a:lnRef idx="1">
+            <a:schemeClr val="accent1"/>
+          </a:lnRef>
+          <a:fillRef idx="3">
+            <a:schemeClr val="accent1"/>
+          </a:fillRef>
+          <a:effectRef idx="2">
+            <a:schemeClr val="accent1"/>
+          </a:effectRef>
+          <a:fontRef idx="minor">
+            <a:schemeClr val="lt1"/>
+          </a:fontRef>
+        </p:style>
+        <p:txBody>
+          <a:bodyPr rtlCol="0" anchor="ctr"/>
+          <a:lstStyle/>
+          <a:p>
+            <a:pPr algn="ctr"/>
+          </a:p>
+        </p:txBody>
+      </p:sp>
+      <p:sp>
+        <p:nvSpPr>
+          <p:cNvPr id="4" name="Rectangle 3"/>
+          <p:cNvSpPr/>
+          <p:nvPr/>
+        </p:nvSpPr>
+        <p:spPr>
+          <a:xfrm>
+            <a:off x="731520" y="1828800"/>
+            <a:ext cx="1810512" cy="109728"/>
+          </a:xfrm>
+          <a:prstGeom prst="rect">
+            <a:avLst/>
+          </a:prstGeom>
+          <a:solidFill>
+            <a:srgbClr val="EA580C"/>
+          </a:solidFill>
+          <a:ln>
+            <a:noFill/>
+          </a:ln>
+        </p:spPr>
+        <p:style>
+          <a:lnRef idx="1">
+            <a:schemeClr val="accent1"/>
+          </a:lnRef>
+          <a:fillRef idx="3">
+            <a:schemeClr val="accent1"/>
+          </a:fillRef>
+          <a:effectRef idx="2">
+            <a:schemeClr val="accent1"/>
+          </a:effectRef>
+          <a:fontRef idx="minor">
+            <a:schemeClr val="lt1"/>
+          </a:fontRef>
+        </p:style>
+        <p:txBody>
+          <a:bodyPr rtlCol="0" anchor="ctr"/>
+          <a:lstStyle/>
+          <a:p>
+            <a:pPr algn="ctr"/>
+          </a:p>
+        </p:txBody>
+      </p:sp>
+      <p:sp>
+        <p:nvSpPr>
+          <p:cNvPr id="5" name="TextBox 4"/>
           <p:cNvSpPr txBox="1"/>
           <p:nvPr/>
         </p:nvSpPr>
         <p:spPr>
           <a:xfrm>
-            <a:off x="731520" y="1371600"/>
-            <a:ext cx="7680960" cy="3200400"/>
+            <a:off x="841248" y="2103120"/>
+            <a:ext cx="1591056" cy="2286000"/>
           </a:xfrm>
           <a:prstGeom prst="rect">
             <a:avLst/>
@@ -3638,46 +4713,442 @@
           <a:p>
             <a:pPr>
               <a:spcAft>
-                <a:spcPts val="1400"/>
+                <a:spcPts val="800"/>
               </a:spcAft>
-              <a:defRPr sz="1500">
-                <a:solidFill>
-                  <a:srgbClr val="334155"/>
+              <a:defRPr sz="1400" b="1">
+                <a:solidFill>
+                  <a:srgbClr val="0F172A"/>
                 </a:solidFill>
               </a:defRPr>
             </a:pPr>
             <a:r>
-              <a:t>• Konfigurasi string optimal: Tegangan Vmp terjaga pada efisiensi MPPT tertinggi</a:t>
-            </a:r>
-          </a:p>
+              <a:t>CAPEX Transparan</a:t>
+            </a:r>
+          </a:p>
+          <a:p>
+            <a:pPr>
+              <a:defRPr sz="1100">
+                <a:solidFill>
+                  <a:srgbClr val="475569"/>
+                </a:solidFill>
+              </a:defRPr>
+            </a:pPr>
+            <a:r>
+              <a:t>Rincian biaya total material &amp; instalasi</a:t>
+            </a:r>
+          </a:p>
+        </p:txBody>
+      </p:sp>
+      <p:sp>
+        <p:nvSpPr>
+          <p:cNvPr id="6" name="Rounded Rectangle 5"/>
+          <p:cNvSpPr/>
+          <p:nvPr/>
+        </p:nvSpPr>
+        <p:spPr>
+          <a:xfrm>
+            <a:off x="2670048" y="1828800"/>
+            <a:ext cx="1810512" cy="2651760"/>
+          </a:xfrm>
+          <a:prstGeom prst="roundRect">
+            <a:avLst/>
+          </a:prstGeom>
+          <a:solidFill>
+            <a:srgbClr val="F8FAFC"/>
+          </a:solidFill>
+          <a:ln>
+            <a:solidFill>
+              <a:srgbClr val="E2E8F0"/>
+            </a:solidFill>
+          </a:ln>
+        </p:spPr>
+        <p:style>
+          <a:lnRef idx="1">
+            <a:schemeClr val="accent1"/>
+          </a:lnRef>
+          <a:fillRef idx="3">
+            <a:schemeClr val="accent1"/>
+          </a:fillRef>
+          <a:effectRef idx="2">
+            <a:schemeClr val="accent1"/>
+          </a:effectRef>
+          <a:fontRef idx="minor">
+            <a:schemeClr val="lt1"/>
+          </a:fontRef>
+        </p:style>
+        <p:txBody>
+          <a:bodyPr rtlCol="0" anchor="ctr"/>
+          <a:lstStyle/>
+          <a:p>
+            <a:pPr algn="ctr"/>
+          </a:p>
+        </p:txBody>
+      </p:sp>
+      <p:sp>
+        <p:nvSpPr>
+          <p:cNvPr id="7" name="Rectangle 6"/>
+          <p:cNvSpPr/>
+          <p:nvPr/>
+        </p:nvSpPr>
+        <p:spPr>
+          <a:xfrm>
+            <a:off x="2670048" y="1828800"/>
+            <a:ext cx="1810512" cy="109728"/>
+          </a:xfrm>
+          <a:prstGeom prst="rect">
+            <a:avLst/>
+          </a:prstGeom>
+          <a:solidFill>
+            <a:srgbClr val="EA580C"/>
+          </a:solidFill>
+          <a:ln>
+            <a:noFill/>
+          </a:ln>
+        </p:spPr>
+        <p:style>
+          <a:lnRef idx="1">
+            <a:schemeClr val="accent1"/>
+          </a:lnRef>
+          <a:fillRef idx="3">
+            <a:schemeClr val="accent1"/>
+          </a:fillRef>
+          <a:effectRef idx="2">
+            <a:schemeClr val="accent1"/>
+          </a:effectRef>
+          <a:fontRef idx="minor">
+            <a:schemeClr val="lt1"/>
+          </a:fontRef>
+        </p:style>
+        <p:txBody>
+          <a:bodyPr rtlCol="0" anchor="ctr"/>
+          <a:lstStyle/>
+          <a:p>
+            <a:pPr algn="ctr"/>
+          </a:p>
+        </p:txBody>
+      </p:sp>
+      <p:sp>
+        <p:nvSpPr>
+          <p:cNvPr id="8" name="TextBox 7"/>
+          <p:cNvSpPr txBox="1"/>
+          <p:nvPr/>
+        </p:nvSpPr>
+        <p:spPr>
+          <a:xfrm>
+            <a:off x="2779776" y="2103120"/>
+            <a:ext cx="1591056" cy="2286000"/>
+          </a:xfrm>
+          <a:prstGeom prst="rect">
+            <a:avLst/>
+          </a:prstGeom>
+          <a:noFill/>
+        </p:spPr>
+        <p:txBody>
+          <a:bodyPr wrap="square">
+            <a:spAutoFit/>
+          </a:bodyPr>
+          <a:lstStyle/>
           <a:p>
             <a:pPr>
               <a:spcAft>
-                <a:spcPts val="1400"/>
+                <a:spcPts val="800"/>
               </a:spcAft>
-              <a:defRPr sz="1500">
-                <a:solidFill>
-                  <a:srgbClr val="334155"/>
+              <a:defRPr sz="1400" b="1">
+                <a:solidFill>
+                  <a:srgbClr val="0F172A"/>
                 </a:solidFill>
               </a:defRPr>
             </a:pPr>
             <a:r>
-              <a:t>• Keamanan Voc ekstrem pada suhu terdingin (di bawah batas maksimum inverter)</a:t>
-            </a:r>
-          </a:p>
+              <a:t>Payback (BEP)</a:t>
+            </a:r>
+          </a:p>
+          <a:p>
+            <a:pPr>
+              <a:defRPr sz="1100">
+                <a:solidFill>
+                  <a:srgbClr val="475569"/>
+                </a:solidFill>
+              </a:defRPr>
+            </a:pPr>
+            <a:r>
+              <a:t>Estimasi titik impas cepat 4 - 6 tahun</a:t>
+            </a:r>
+          </a:p>
+        </p:txBody>
+      </p:sp>
+      <p:sp>
+        <p:nvSpPr>
+          <p:cNvPr id="9" name="Rounded Rectangle 8"/>
+          <p:cNvSpPr/>
+          <p:nvPr/>
+        </p:nvSpPr>
+        <p:spPr>
+          <a:xfrm>
+            <a:off x="4608576" y="1828800"/>
+            <a:ext cx="1810512" cy="2651760"/>
+          </a:xfrm>
+          <a:prstGeom prst="roundRect">
+            <a:avLst/>
+          </a:prstGeom>
+          <a:solidFill>
+            <a:srgbClr val="F8FAFC"/>
+          </a:solidFill>
+          <a:ln>
+            <a:solidFill>
+              <a:srgbClr val="E2E8F0"/>
+            </a:solidFill>
+          </a:ln>
+        </p:spPr>
+        <p:style>
+          <a:lnRef idx="1">
+            <a:schemeClr val="accent1"/>
+          </a:lnRef>
+          <a:fillRef idx="3">
+            <a:schemeClr val="accent1"/>
+          </a:fillRef>
+          <a:effectRef idx="2">
+            <a:schemeClr val="accent1"/>
+          </a:effectRef>
+          <a:fontRef idx="minor">
+            <a:schemeClr val="lt1"/>
+          </a:fontRef>
+        </p:style>
+        <p:txBody>
+          <a:bodyPr rtlCol="0" anchor="ctr"/>
+          <a:lstStyle/>
+          <a:p>
+            <a:pPr algn="ctr"/>
+          </a:p>
+        </p:txBody>
+      </p:sp>
+      <p:sp>
+        <p:nvSpPr>
+          <p:cNvPr id="10" name="Rectangle 9"/>
+          <p:cNvSpPr/>
+          <p:nvPr/>
+        </p:nvSpPr>
+        <p:spPr>
+          <a:xfrm>
+            <a:off x="4608576" y="1828800"/>
+            <a:ext cx="1810512" cy="109728"/>
+          </a:xfrm>
+          <a:prstGeom prst="rect">
+            <a:avLst/>
+          </a:prstGeom>
+          <a:solidFill>
+            <a:srgbClr val="EA580C"/>
+          </a:solidFill>
+          <a:ln>
+            <a:noFill/>
+          </a:ln>
+        </p:spPr>
+        <p:style>
+          <a:lnRef idx="1">
+            <a:schemeClr val="accent1"/>
+          </a:lnRef>
+          <a:fillRef idx="3">
+            <a:schemeClr val="accent1"/>
+          </a:fillRef>
+          <a:effectRef idx="2">
+            <a:schemeClr val="accent1"/>
+          </a:effectRef>
+          <a:fontRef idx="minor">
+            <a:schemeClr val="lt1"/>
+          </a:fontRef>
+        </p:style>
+        <p:txBody>
+          <a:bodyPr rtlCol="0" anchor="ctr"/>
+          <a:lstStyle/>
+          <a:p>
+            <a:pPr algn="ctr"/>
+          </a:p>
+        </p:txBody>
+      </p:sp>
+      <p:sp>
+        <p:nvSpPr>
+          <p:cNvPr id="11" name="TextBox 10"/>
+          <p:cNvSpPr txBox="1"/>
+          <p:nvPr/>
+        </p:nvSpPr>
+        <p:spPr>
+          <a:xfrm>
+            <a:off x="4718304" y="2103120"/>
+            <a:ext cx="1591056" cy="2286000"/>
+          </a:xfrm>
+          <a:prstGeom prst="rect">
+            <a:avLst/>
+          </a:prstGeom>
+          <a:noFill/>
+        </p:spPr>
+        <p:txBody>
+          <a:bodyPr wrap="square">
+            <a:spAutoFit/>
+          </a:bodyPr>
+          <a:lstStyle/>
           <a:p>
             <a:pPr>
               <a:spcAft>
-                <a:spcPts val="1400"/>
+                <a:spcPts val="800"/>
               </a:spcAft>
-              <a:defRPr sz="1500">
-                <a:solidFill>
-                  <a:srgbClr val="334155"/>
+              <a:defRPr sz="1400" b="1">
+                <a:solidFill>
+                  <a:srgbClr val="0F172A"/>
                 </a:solidFill>
               </a:defRPr>
             </a:pPr>
             <a:r>
-              <a:t>• Proteksi arus hubung singkat dan proteksi lonjakan arus (Surge Protection)</a:t>
+              <a:t>LCOE Kompetitif</a:t>
+            </a:r>
+          </a:p>
+          <a:p>
+            <a:pPr>
+              <a:defRPr sz="1100">
+                <a:solidFill>
+                  <a:srgbClr val="475569"/>
+                </a:solidFill>
+              </a:defRPr>
+            </a:pPr>
+            <a:r>
+              <a:t>Biaya pokok per kWh di bawah PLN</a:t>
+            </a:r>
+          </a:p>
+        </p:txBody>
+      </p:sp>
+      <p:sp>
+        <p:nvSpPr>
+          <p:cNvPr id="12" name="Rounded Rectangle 11"/>
+          <p:cNvSpPr/>
+          <p:nvPr/>
+        </p:nvSpPr>
+        <p:spPr>
+          <a:xfrm>
+            <a:off x="6547104" y="1828800"/>
+            <a:ext cx="1810512" cy="2651760"/>
+          </a:xfrm>
+          <a:prstGeom prst="roundRect">
+            <a:avLst/>
+          </a:prstGeom>
+          <a:solidFill>
+            <a:srgbClr val="F8FAFC"/>
+          </a:solidFill>
+          <a:ln>
+            <a:solidFill>
+              <a:srgbClr val="E2E8F0"/>
+            </a:solidFill>
+          </a:ln>
+        </p:spPr>
+        <p:style>
+          <a:lnRef idx="1">
+            <a:schemeClr val="accent1"/>
+          </a:lnRef>
+          <a:fillRef idx="3">
+            <a:schemeClr val="accent1"/>
+          </a:fillRef>
+          <a:effectRef idx="2">
+            <a:schemeClr val="accent1"/>
+          </a:effectRef>
+          <a:fontRef idx="minor">
+            <a:schemeClr val="lt1"/>
+          </a:fontRef>
+        </p:style>
+        <p:txBody>
+          <a:bodyPr rtlCol="0" anchor="ctr"/>
+          <a:lstStyle/>
+          <a:p>
+            <a:pPr algn="ctr"/>
+          </a:p>
+        </p:txBody>
+      </p:sp>
+      <p:sp>
+        <p:nvSpPr>
+          <p:cNvPr id="13" name="Rectangle 12"/>
+          <p:cNvSpPr/>
+          <p:nvPr/>
+        </p:nvSpPr>
+        <p:spPr>
+          <a:xfrm>
+            <a:off x="6547104" y="1828800"/>
+            <a:ext cx="1810512" cy="109728"/>
+          </a:xfrm>
+          <a:prstGeom prst="rect">
+            <a:avLst/>
+          </a:prstGeom>
+          <a:solidFill>
+            <a:srgbClr val="EA580C"/>
+          </a:solidFill>
+          <a:ln>
+            <a:noFill/>
+          </a:ln>
+        </p:spPr>
+        <p:style>
+          <a:lnRef idx="1">
+            <a:schemeClr val="accent1"/>
+          </a:lnRef>
+          <a:fillRef idx="3">
+            <a:schemeClr val="accent1"/>
+          </a:fillRef>
+          <a:effectRef idx="2">
+            <a:schemeClr val="accent1"/>
+          </a:effectRef>
+          <a:fontRef idx="minor">
+            <a:schemeClr val="lt1"/>
+          </a:fontRef>
+        </p:style>
+        <p:txBody>
+          <a:bodyPr rtlCol="0" anchor="ctr"/>
+          <a:lstStyle/>
+          <a:p>
+            <a:pPr algn="ctr"/>
+          </a:p>
+        </p:txBody>
+      </p:sp>
+      <p:sp>
+        <p:nvSpPr>
+          <p:cNvPr id="14" name="TextBox 13"/>
+          <p:cNvSpPr txBox="1"/>
+          <p:nvPr/>
+        </p:nvSpPr>
+        <p:spPr>
+          <a:xfrm>
+            <a:off x="6656832" y="2103120"/>
+            <a:ext cx="1591056" cy="2286000"/>
+          </a:xfrm>
+          <a:prstGeom prst="rect">
+            <a:avLst/>
+          </a:prstGeom>
+          <a:noFill/>
+        </p:spPr>
+        <p:txBody>
+          <a:bodyPr wrap="square">
+            <a:spAutoFit/>
+          </a:bodyPr>
+          <a:lstStyle/>
+          <a:p>
+            <a:pPr>
+              <a:spcAft>
+                <a:spcPts val="800"/>
+              </a:spcAft>
+              <a:defRPr sz="1400" b="1">
+                <a:solidFill>
+                  <a:srgbClr val="0F172A"/>
+                </a:solidFill>
+              </a:defRPr>
+            </a:pPr>
+            <a:r>
+              <a:t>NPV Positif</a:t>
+            </a:r>
+          </a:p>
+          <a:p>
+            <a:pPr>
+              <a:defRPr sz="1100">
+                <a:solidFill>
+                  <a:srgbClr val="475569"/>
+                </a:solidFill>
+              </a:defRPr>
+            </a:pPr>
+            <a:r>
+              <a:t>Akumulasi keuntungan 25 tahun</a:t>
             </a:r>
           </a:p>
         </p:txBody>
@@ -3708,8 +5179,8 @@
         </p:nvSpPr>
         <p:spPr>
           <a:xfrm>
-            <a:off x="731520" y="548640"/>
-            <a:ext cx="7680960" cy="731520"/>
+            <a:off x="731520" y="457200"/>
+            <a:ext cx="7680960" cy="914400"/>
           </a:xfrm>
           <a:prstGeom prst="rect">
             <a:avLst/>
@@ -3723,28 +5194,131 @@
           <a:lstStyle/>
           <a:p>
             <a:pPr>
-              <a:defRPr sz="2200" b="1">
+              <a:defRPr sz="2000" b="1">
                 <a:solidFill>
                   <a:srgbClr val="0F172A"/>
                 </a:solidFill>
               </a:defRPr>
             </a:pPr>
             <a:r>
-              <a:t>ANALISIS FINANSIAL &amp; KELAYAKAN</a:t>
-            </a:r>
-          </a:p>
-        </p:txBody>
-      </p:sp>
-      <p:sp>
-        <p:nvSpPr>
-          <p:cNvPr id="3" name="TextBox 2"/>
+              <a:t>ROADMAP EKSEKUSI PROYEK</a:t>
+            </a:r>
+          </a:p>
+          <a:p>
+            <a:pPr>
+              <a:spcBef>
+                <a:spcPts val="400"/>
+              </a:spcBef>
+              <a:defRPr sz="1300">
+                <a:solidFill>
+                  <a:srgbClr val="475569"/>
+                </a:solidFill>
+              </a:defRPr>
+            </a:pPr>
+            <a:r>
+              <a:t>Tahapan terstruktur dari audit awal hingga komisioning sistem</a:t>
+            </a:r>
+          </a:p>
+        </p:txBody>
+      </p:sp>
+      <p:sp>
+        <p:nvSpPr>
+          <p:cNvPr id="3" name="Rounded Rectangle 2"/>
+          <p:cNvSpPr/>
+          <p:nvPr/>
+        </p:nvSpPr>
+        <p:spPr>
+          <a:xfrm>
+            <a:off x="548640" y="1828800"/>
+            <a:ext cx="1499616" cy="2651760"/>
+          </a:xfrm>
+          <a:prstGeom prst="roundRect">
+            <a:avLst/>
+          </a:prstGeom>
+          <a:solidFill>
+            <a:srgbClr val="F8FAFC"/>
+          </a:solidFill>
+          <a:ln>
+            <a:solidFill>
+              <a:srgbClr val="E2E8F0"/>
+            </a:solidFill>
+          </a:ln>
+        </p:spPr>
+        <p:style>
+          <a:lnRef idx="1">
+            <a:schemeClr val="accent1"/>
+          </a:lnRef>
+          <a:fillRef idx="3">
+            <a:schemeClr val="accent1"/>
+          </a:fillRef>
+          <a:effectRef idx="2">
+            <a:schemeClr val="accent1"/>
+          </a:effectRef>
+          <a:fontRef idx="minor">
+            <a:schemeClr val="lt1"/>
+          </a:fontRef>
+        </p:style>
+        <p:txBody>
+          <a:bodyPr rtlCol="0" anchor="ctr"/>
+          <a:lstStyle/>
+          <a:p>
+            <a:pPr algn="ctr"/>
+          </a:p>
+        </p:txBody>
+      </p:sp>
+      <p:sp>
+        <p:nvSpPr>
+          <p:cNvPr id="4" name="Rectangle 3"/>
+          <p:cNvSpPr/>
+          <p:nvPr/>
+        </p:nvSpPr>
+        <p:spPr>
+          <a:xfrm>
+            <a:off x="548640" y="1828800"/>
+            <a:ext cx="1499616" cy="109728"/>
+          </a:xfrm>
+          <a:prstGeom prst="rect">
+            <a:avLst/>
+          </a:prstGeom>
+          <a:solidFill>
+            <a:srgbClr val="0F172A"/>
+          </a:solidFill>
+          <a:ln>
+            <a:noFill/>
+          </a:ln>
+        </p:spPr>
+        <p:style>
+          <a:lnRef idx="1">
+            <a:schemeClr val="accent1"/>
+          </a:lnRef>
+          <a:fillRef idx="3">
+            <a:schemeClr val="accent1"/>
+          </a:fillRef>
+          <a:effectRef idx="2">
+            <a:schemeClr val="accent1"/>
+          </a:effectRef>
+          <a:fontRef idx="minor">
+            <a:schemeClr val="lt1"/>
+          </a:fontRef>
+        </p:style>
+        <p:txBody>
+          <a:bodyPr rtlCol="0" anchor="ctr"/>
+          <a:lstStyle/>
+          <a:p>
+            <a:pPr algn="ctr"/>
+          </a:p>
+        </p:txBody>
+      </p:sp>
+      <p:sp>
+        <p:nvSpPr>
+          <p:cNvPr id="5" name="TextBox 4"/>
           <p:cNvSpPr txBox="1"/>
           <p:nvPr/>
         </p:nvSpPr>
         <p:spPr>
           <a:xfrm>
-            <a:off x="731520" y="1371600"/>
-            <a:ext cx="7680960" cy="3200400"/>
+            <a:off x="640080" y="2103120"/>
+            <a:ext cx="1316736" cy="2286000"/>
           </a:xfrm>
           <a:prstGeom prst="rect">
             <a:avLst/>
@@ -3759,61 +5333,580 @@
           <a:p>
             <a:pPr>
               <a:spcAft>
-                <a:spcPts val="1400"/>
+                <a:spcPts val="800"/>
               </a:spcAft>
-              <a:defRPr sz="1500">
-                <a:solidFill>
-                  <a:srgbClr val="334155"/>
+              <a:defRPr sz="1300" b="1">
+                <a:solidFill>
+                  <a:srgbClr val="EA580C"/>
                 </a:solidFill>
               </a:defRPr>
             </a:pPr>
             <a:r>
-              <a:t>• CAPEX Transparan: Rincian investasi modul, inverter, BoS, dan perizinan</a:t>
-            </a:r>
-          </a:p>
+              <a:t>1. Survey</a:t>
+            </a:r>
+          </a:p>
+          <a:p>
+            <a:pPr>
+              <a:defRPr sz="1100">
+                <a:solidFill>
+                  <a:srgbClr val="475569"/>
+                </a:solidFill>
+              </a:defRPr>
+            </a:pPr>
+            <a:r>
+              <a:t>Audit fisik &amp; beban</a:t>
+            </a:r>
+          </a:p>
+        </p:txBody>
+      </p:sp>
+      <p:sp>
+        <p:nvSpPr>
+          <p:cNvPr id="6" name="Rounded Rectangle 5"/>
+          <p:cNvSpPr/>
+          <p:nvPr/>
+        </p:nvSpPr>
+        <p:spPr>
+          <a:xfrm>
+            <a:off x="2157984" y="1828800"/>
+            <a:ext cx="1499616" cy="2651760"/>
+          </a:xfrm>
+          <a:prstGeom prst="roundRect">
+            <a:avLst/>
+          </a:prstGeom>
+          <a:solidFill>
+            <a:srgbClr val="F8FAFC"/>
+          </a:solidFill>
+          <a:ln>
+            <a:solidFill>
+              <a:srgbClr val="E2E8F0"/>
+            </a:solidFill>
+          </a:ln>
+        </p:spPr>
+        <p:style>
+          <a:lnRef idx="1">
+            <a:schemeClr val="accent1"/>
+          </a:lnRef>
+          <a:fillRef idx="3">
+            <a:schemeClr val="accent1"/>
+          </a:fillRef>
+          <a:effectRef idx="2">
+            <a:schemeClr val="accent1"/>
+          </a:effectRef>
+          <a:fontRef idx="minor">
+            <a:schemeClr val="lt1"/>
+          </a:fontRef>
+        </p:style>
+        <p:txBody>
+          <a:bodyPr rtlCol="0" anchor="ctr"/>
+          <a:lstStyle/>
+          <a:p>
+            <a:pPr algn="ctr"/>
+          </a:p>
+        </p:txBody>
+      </p:sp>
+      <p:sp>
+        <p:nvSpPr>
+          <p:cNvPr id="7" name="Rectangle 6"/>
+          <p:cNvSpPr/>
+          <p:nvPr/>
+        </p:nvSpPr>
+        <p:spPr>
+          <a:xfrm>
+            <a:off x="2157984" y="1828800"/>
+            <a:ext cx="1499616" cy="109728"/>
+          </a:xfrm>
+          <a:prstGeom prst="rect">
+            <a:avLst/>
+          </a:prstGeom>
+          <a:solidFill>
+            <a:srgbClr val="0F172A"/>
+          </a:solidFill>
+          <a:ln>
+            <a:noFill/>
+          </a:ln>
+        </p:spPr>
+        <p:style>
+          <a:lnRef idx="1">
+            <a:schemeClr val="accent1"/>
+          </a:lnRef>
+          <a:fillRef idx="3">
+            <a:schemeClr val="accent1"/>
+          </a:fillRef>
+          <a:effectRef idx="2">
+            <a:schemeClr val="accent1"/>
+          </a:effectRef>
+          <a:fontRef idx="minor">
+            <a:schemeClr val="lt1"/>
+          </a:fontRef>
+        </p:style>
+        <p:txBody>
+          <a:bodyPr rtlCol="0" anchor="ctr"/>
+          <a:lstStyle/>
+          <a:p>
+            <a:pPr algn="ctr"/>
+          </a:p>
+        </p:txBody>
+      </p:sp>
+      <p:sp>
+        <p:nvSpPr>
+          <p:cNvPr id="8" name="TextBox 7"/>
+          <p:cNvSpPr txBox="1"/>
+          <p:nvPr/>
+        </p:nvSpPr>
+        <p:spPr>
+          <a:xfrm>
+            <a:off x="2249424" y="2103120"/>
+            <a:ext cx="1316736" cy="2286000"/>
+          </a:xfrm>
+          <a:prstGeom prst="rect">
+            <a:avLst/>
+          </a:prstGeom>
+          <a:noFill/>
+        </p:spPr>
+        <p:txBody>
+          <a:bodyPr wrap="square">
+            <a:spAutoFit/>
+          </a:bodyPr>
+          <a:lstStyle/>
           <a:p>
             <a:pPr>
               <a:spcAft>
-                <a:spcPts val="1400"/>
+                <a:spcPts val="800"/>
               </a:spcAft>
-              <a:defRPr sz="1500">
-                <a:solidFill>
-                  <a:srgbClr val="334155"/>
+              <a:defRPr sz="1300" b="1">
+                <a:solidFill>
+                  <a:srgbClr val="EA580C"/>
                 </a:solidFill>
               </a:defRPr>
             </a:pPr>
             <a:r>
-              <a:t>• LCOE Kompetitif: Harga pokok energi per kWh jauh di bawah tarif PLN</a:t>
-            </a:r>
-          </a:p>
+              <a:t>2. DED</a:t>
+            </a:r>
+          </a:p>
+          <a:p>
+            <a:pPr>
+              <a:defRPr sz="1100">
+                <a:solidFill>
+                  <a:srgbClr val="475569"/>
+                </a:solidFill>
+              </a:defRPr>
+            </a:pPr>
+            <a:r>
+              <a:t>Simulasi desain &amp; desain</a:t>
+            </a:r>
+          </a:p>
+        </p:txBody>
+      </p:sp>
+      <p:sp>
+        <p:nvSpPr>
+          <p:cNvPr id="9" name="Rounded Rectangle 8"/>
+          <p:cNvSpPr/>
+          <p:nvPr/>
+        </p:nvSpPr>
+        <p:spPr>
+          <a:xfrm>
+            <a:off x="3767328" y="1828800"/>
+            <a:ext cx="1499616" cy="2651760"/>
+          </a:xfrm>
+          <a:prstGeom prst="roundRect">
+            <a:avLst/>
+          </a:prstGeom>
+          <a:solidFill>
+            <a:srgbClr val="F8FAFC"/>
+          </a:solidFill>
+          <a:ln>
+            <a:solidFill>
+              <a:srgbClr val="E2E8F0"/>
+            </a:solidFill>
+          </a:ln>
+        </p:spPr>
+        <p:style>
+          <a:lnRef idx="1">
+            <a:schemeClr val="accent1"/>
+          </a:lnRef>
+          <a:fillRef idx="3">
+            <a:schemeClr val="accent1"/>
+          </a:fillRef>
+          <a:effectRef idx="2">
+            <a:schemeClr val="accent1"/>
+          </a:effectRef>
+          <a:fontRef idx="minor">
+            <a:schemeClr val="lt1"/>
+          </a:fontRef>
+        </p:style>
+        <p:txBody>
+          <a:bodyPr rtlCol="0" anchor="ctr"/>
+          <a:lstStyle/>
+          <a:p>
+            <a:pPr algn="ctr"/>
+          </a:p>
+        </p:txBody>
+      </p:sp>
+      <p:sp>
+        <p:nvSpPr>
+          <p:cNvPr id="10" name="Rectangle 9"/>
+          <p:cNvSpPr/>
+          <p:nvPr/>
+        </p:nvSpPr>
+        <p:spPr>
+          <a:xfrm>
+            <a:off x="3767328" y="1828800"/>
+            <a:ext cx="1499616" cy="109728"/>
+          </a:xfrm>
+          <a:prstGeom prst="rect">
+            <a:avLst/>
+          </a:prstGeom>
+          <a:solidFill>
+            <a:srgbClr val="0F172A"/>
+          </a:solidFill>
+          <a:ln>
+            <a:noFill/>
+          </a:ln>
+        </p:spPr>
+        <p:style>
+          <a:lnRef idx="1">
+            <a:schemeClr val="accent1"/>
+          </a:lnRef>
+          <a:fillRef idx="3">
+            <a:schemeClr val="accent1"/>
+          </a:fillRef>
+          <a:effectRef idx="2">
+            <a:schemeClr val="accent1"/>
+          </a:effectRef>
+          <a:fontRef idx="minor">
+            <a:schemeClr val="lt1"/>
+          </a:fontRef>
+        </p:style>
+        <p:txBody>
+          <a:bodyPr rtlCol="0" anchor="ctr"/>
+          <a:lstStyle/>
+          <a:p>
+            <a:pPr algn="ctr"/>
+          </a:p>
+        </p:txBody>
+      </p:sp>
+      <p:sp>
+        <p:nvSpPr>
+          <p:cNvPr id="11" name="TextBox 10"/>
+          <p:cNvSpPr txBox="1"/>
+          <p:nvPr/>
+        </p:nvSpPr>
+        <p:spPr>
+          <a:xfrm>
+            <a:off x="3858768" y="2103120"/>
+            <a:ext cx="1316736" cy="2286000"/>
+          </a:xfrm>
+          <a:prstGeom prst="rect">
+            <a:avLst/>
+          </a:prstGeom>
+          <a:noFill/>
+        </p:spPr>
+        <p:txBody>
+          <a:bodyPr wrap="square">
+            <a:spAutoFit/>
+          </a:bodyPr>
+          <a:lstStyle/>
           <a:p>
             <a:pPr>
               <a:spcAft>
-                <a:spcPts val="1400"/>
+                <a:spcPts val="800"/>
               </a:spcAft>
-              <a:defRPr sz="1500">
-                <a:solidFill>
-                  <a:srgbClr val="334155"/>
+              <a:defRPr sz="1300" b="1">
+                <a:solidFill>
+                  <a:srgbClr val="EA580C"/>
                 </a:solidFill>
               </a:defRPr>
             </a:pPr>
             <a:r>
-              <a:t>• Payback Period (BEP): Pengembalian modal cepat (4 - 6 tahun)</a:t>
-            </a:r>
-          </a:p>
+              <a:t>3. Perizinan</a:t>
+            </a:r>
+          </a:p>
+          <a:p>
+            <a:pPr>
+              <a:defRPr sz="1100">
+                <a:solidFill>
+                  <a:srgbClr val="475569"/>
+                </a:solidFill>
+              </a:defRPr>
+            </a:pPr>
+            <a:r>
+              <a:t>Paralel PLN &amp; SLO</a:t>
+            </a:r>
+          </a:p>
+        </p:txBody>
+      </p:sp>
+      <p:sp>
+        <p:nvSpPr>
+          <p:cNvPr id="12" name="Rounded Rectangle 11"/>
+          <p:cNvSpPr/>
+          <p:nvPr/>
+        </p:nvSpPr>
+        <p:spPr>
+          <a:xfrm>
+            <a:off x="5376672" y="1828800"/>
+            <a:ext cx="1499616" cy="2651760"/>
+          </a:xfrm>
+          <a:prstGeom prst="roundRect">
+            <a:avLst/>
+          </a:prstGeom>
+          <a:solidFill>
+            <a:srgbClr val="F8FAFC"/>
+          </a:solidFill>
+          <a:ln>
+            <a:solidFill>
+              <a:srgbClr val="E2E8F0"/>
+            </a:solidFill>
+          </a:ln>
+        </p:spPr>
+        <p:style>
+          <a:lnRef idx="1">
+            <a:schemeClr val="accent1"/>
+          </a:lnRef>
+          <a:fillRef idx="3">
+            <a:schemeClr val="accent1"/>
+          </a:fillRef>
+          <a:effectRef idx="2">
+            <a:schemeClr val="accent1"/>
+          </a:effectRef>
+          <a:fontRef idx="minor">
+            <a:schemeClr val="lt1"/>
+          </a:fontRef>
+        </p:style>
+        <p:txBody>
+          <a:bodyPr rtlCol="0" anchor="ctr"/>
+          <a:lstStyle/>
+          <a:p>
+            <a:pPr algn="ctr"/>
+          </a:p>
+        </p:txBody>
+      </p:sp>
+      <p:sp>
+        <p:nvSpPr>
+          <p:cNvPr id="13" name="Rectangle 12"/>
+          <p:cNvSpPr/>
+          <p:nvPr/>
+        </p:nvSpPr>
+        <p:spPr>
+          <a:xfrm>
+            <a:off x="5376672" y="1828800"/>
+            <a:ext cx="1499616" cy="109728"/>
+          </a:xfrm>
+          <a:prstGeom prst="rect">
+            <a:avLst/>
+          </a:prstGeom>
+          <a:solidFill>
+            <a:srgbClr val="0F172A"/>
+          </a:solidFill>
+          <a:ln>
+            <a:noFill/>
+          </a:ln>
+        </p:spPr>
+        <p:style>
+          <a:lnRef idx="1">
+            <a:schemeClr val="accent1"/>
+          </a:lnRef>
+          <a:fillRef idx="3">
+            <a:schemeClr val="accent1"/>
+          </a:fillRef>
+          <a:effectRef idx="2">
+            <a:schemeClr val="accent1"/>
+          </a:effectRef>
+          <a:fontRef idx="minor">
+            <a:schemeClr val="lt1"/>
+          </a:fontRef>
+        </p:style>
+        <p:txBody>
+          <a:bodyPr rtlCol="0" anchor="ctr"/>
+          <a:lstStyle/>
+          <a:p>
+            <a:pPr algn="ctr"/>
+          </a:p>
+        </p:txBody>
+      </p:sp>
+      <p:sp>
+        <p:nvSpPr>
+          <p:cNvPr id="14" name="TextBox 13"/>
+          <p:cNvSpPr txBox="1"/>
+          <p:nvPr/>
+        </p:nvSpPr>
+        <p:spPr>
+          <a:xfrm>
+            <a:off x="5468112" y="2103120"/>
+            <a:ext cx="1316736" cy="2286000"/>
+          </a:xfrm>
+          <a:prstGeom prst="rect">
+            <a:avLst/>
+          </a:prstGeom>
+          <a:noFill/>
+        </p:spPr>
+        <p:txBody>
+          <a:bodyPr wrap="square">
+            <a:spAutoFit/>
+          </a:bodyPr>
+          <a:lstStyle/>
           <a:p>
             <a:pPr>
               <a:spcAft>
-                <a:spcPts val="1400"/>
+                <a:spcPts val="800"/>
               </a:spcAft>
-              <a:defRPr sz="1500">
-                <a:solidFill>
-                  <a:srgbClr val="334155"/>
+              <a:defRPr sz="1300" b="1">
+                <a:solidFill>
+                  <a:srgbClr val="EA580C"/>
                 </a:solidFill>
               </a:defRPr>
             </a:pPr>
             <a:r>
-              <a:t>• Net Present Value (NPV): Proyeksi akumulasi keuntungan positif 25 tahun</a:t>
+              <a:t>4. Konstruksi</a:t>
+            </a:r>
+          </a:p>
+          <a:p>
+            <a:pPr>
+              <a:defRPr sz="1100">
+                <a:solidFill>
+                  <a:srgbClr val="475569"/>
+                </a:solidFill>
+              </a:defRPr>
+            </a:pPr>
+            <a:r>
+              <a:t>Instalasi &amp; uji fungsi</a:t>
+            </a:r>
+          </a:p>
+        </p:txBody>
+      </p:sp>
+      <p:sp>
+        <p:nvSpPr>
+          <p:cNvPr id="15" name="Rounded Rectangle 14"/>
+          <p:cNvSpPr/>
+          <p:nvPr/>
+        </p:nvSpPr>
+        <p:spPr>
+          <a:xfrm>
+            <a:off x="6986016" y="1828800"/>
+            <a:ext cx="1499616" cy="2651760"/>
+          </a:xfrm>
+          <a:prstGeom prst="roundRect">
+            <a:avLst/>
+          </a:prstGeom>
+          <a:solidFill>
+            <a:srgbClr val="F8FAFC"/>
+          </a:solidFill>
+          <a:ln>
+            <a:solidFill>
+              <a:srgbClr val="E2E8F0"/>
+            </a:solidFill>
+          </a:ln>
+        </p:spPr>
+        <p:style>
+          <a:lnRef idx="1">
+            <a:schemeClr val="accent1"/>
+          </a:lnRef>
+          <a:fillRef idx="3">
+            <a:schemeClr val="accent1"/>
+          </a:fillRef>
+          <a:effectRef idx="2">
+            <a:schemeClr val="accent1"/>
+          </a:effectRef>
+          <a:fontRef idx="minor">
+            <a:schemeClr val="lt1"/>
+          </a:fontRef>
+        </p:style>
+        <p:txBody>
+          <a:bodyPr rtlCol="0" anchor="ctr"/>
+          <a:lstStyle/>
+          <a:p>
+            <a:pPr algn="ctr"/>
+          </a:p>
+        </p:txBody>
+      </p:sp>
+      <p:sp>
+        <p:nvSpPr>
+          <p:cNvPr id="16" name="Rectangle 15"/>
+          <p:cNvSpPr/>
+          <p:nvPr/>
+        </p:nvSpPr>
+        <p:spPr>
+          <a:xfrm>
+            <a:off x="6986016" y="1828800"/>
+            <a:ext cx="1499616" cy="109728"/>
+          </a:xfrm>
+          <a:prstGeom prst="rect">
+            <a:avLst/>
+          </a:prstGeom>
+          <a:solidFill>
+            <a:srgbClr val="0F172A"/>
+          </a:solidFill>
+          <a:ln>
+            <a:noFill/>
+          </a:ln>
+        </p:spPr>
+        <p:style>
+          <a:lnRef idx="1">
+            <a:schemeClr val="accent1"/>
+          </a:lnRef>
+          <a:fillRef idx="3">
+            <a:schemeClr val="accent1"/>
+          </a:fillRef>
+          <a:effectRef idx="2">
+            <a:schemeClr val="accent1"/>
+          </a:effectRef>
+          <a:fontRef idx="minor">
+            <a:schemeClr val="lt1"/>
+          </a:fontRef>
+        </p:style>
+        <p:txBody>
+          <a:bodyPr rtlCol="0" anchor="ctr"/>
+          <a:lstStyle/>
+          <a:p>
+            <a:pPr algn="ctr"/>
+          </a:p>
+        </p:txBody>
+      </p:sp>
+      <p:sp>
+        <p:nvSpPr>
+          <p:cNvPr id="17" name="TextBox 16"/>
+          <p:cNvSpPr txBox="1"/>
+          <p:nvPr/>
+        </p:nvSpPr>
+        <p:spPr>
+          <a:xfrm>
+            <a:off x="7077456" y="2103120"/>
+            <a:ext cx="1316736" cy="2286000"/>
+          </a:xfrm>
+          <a:prstGeom prst="rect">
+            <a:avLst/>
+          </a:prstGeom>
+          <a:noFill/>
+        </p:spPr>
+        <p:txBody>
+          <a:bodyPr wrap="square">
+            <a:spAutoFit/>
+          </a:bodyPr>
+          <a:lstStyle/>
+          <a:p>
+            <a:pPr>
+              <a:spcAft>
+                <a:spcPts val="800"/>
+              </a:spcAft>
+              <a:defRPr sz="1300" b="1">
+                <a:solidFill>
+                  <a:srgbClr val="EA580C"/>
+                </a:solidFill>
+              </a:defRPr>
+            </a:pPr>
+            <a:r>
+              <a:t>5. Operasional</a:t>
+            </a:r>
+          </a:p>
+          <a:p>
+            <a:pPr>
+              <a:defRPr sz="1100">
+                <a:solidFill>
+                  <a:srgbClr val="475569"/>
+                </a:solidFill>
+              </a:defRPr>
+            </a:pPr>
+            <a:r>
+              <a:t>Monitoring &amp; garansi</a:t>
             </a:r>
           </a:p>
         </p:txBody>
@@ -3844,8 +5937,8 @@
         </p:nvSpPr>
         <p:spPr>
           <a:xfrm>
-            <a:off x="731520" y="548640"/>
-            <a:ext cx="7680960" cy="731520"/>
+            <a:off x="731520" y="457200"/>
+            <a:ext cx="7680960" cy="914400"/>
           </a:xfrm>
           <a:prstGeom prst="rect">
             <a:avLst/>
@@ -3859,28 +5952,86 @@
           <a:lstStyle/>
           <a:p>
             <a:pPr>
-              <a:defRPr sz="2200" b="1">
+              <a:defRPr sz="2000" b="1">
                 <a:solidFill>
                   <a:srgbClr val="0F172A"/>
                 </a:solidFill>
               </a:defRPr>
             </a:pPr>
             <a:r>
-              <a:t>ROADMAP EKSEKUSI PROYEK</a:t>
-            </a:r>
-          </a:p>
-        </p:txBody>
-      </p:sp>
-      <p:sp>
-        <p:nvSpPr>
-          <p:cNvPr id="3" name="TextBox 2"/>
+              <a:t>MULAI TRANSISI ENERGI ANDA HARI INI</a:t>
+            </a:r>
+          </a:p>
+          <a:p>
+            <a:pPr>
+              <a:spcBef>
+                <a:spcPts val="400"/>
+              </a:spcBef>
+              <a:defRPr sz="1300">
+                <a:solidFill>
+                  <a:srgbClr val="475569"/>
+                </a:solidFill>
+              </a:defRPr>
+            </a:pPr>
+            <a:r>
+              <a:t>Dapatkan konsultasi teknis, audit profil beban, dan proposal penawaran komprehensif secara gratis.</a:t>
+            </a:r>
+          </a:p>
+        </p:txBody>
+      </p:sp>
+      <p:sp>
+        <p:nvSpPr>
+          <p:cNvPr id="3" name="Rounded Rectangle 2"/>
+          <p:cNvSpPr/>
+          <p:nvPr/>
+        </p:nvSpPr>
+        <p:spPr>
+          <a:xfrm>
+            <a:off x="1371600" y="1645920"/>
+            <a:ext cx="6400800" cy="2743200"/>
+          </a:xfrm>
+          <a:prstGeom prst="roundRect">
+            <a:avLst/>
+          </a:prstGeom>
+          <a:solidFill>
+            <a:srgbClr val="0F172A"/>
+          </a:solidFill>
+          <a:ln>
+            <a:noFill/>
+          </a:ln>
+        </p:spPr>
+        <p:style>
+          <a:lnRef idx="1">
+            <a:schemeClr val="accent1"/>
+          </a:lnRef>
+          <a:fillRef idx="3">
+            <a:schemeClr val="accent1"/>
+          </a:fillRef>
+          <a:effectRef idx="2">
+            <a:schemeClr val="accent1"/>
+          </a:effectRef>
+          <a:fontRef idx="minor">
+            <a:schemeClr val="lt1"/>
+          </a:fontRef>
+        </p:style>
+        <p:txBody>
+          <a:bodyPr rtlCol="0" anchor="ctr"/>
+          <a:lstStyle/>
+          <a:p>
+            <a:pPr algn="ctr"/>
+          </a:p>
+        </p:txBody>
+      </p:sp>
+      <p:sp>
+        <p:nvSpPr>
+          <p:cNvPr id="4" name="TextBox 3"/>
           <p:cNvSpPr txBox="1"/>
           <p:nvPr/>
         </p:nvSpPr>
         <p:spPr>
           <a:xfrm>
-            <a:off x="731520" y="1371600"/>
-            <a:ext cx="7680960" cy="3200400"/>
+            <a:off x="1737360" y="2103120"/>
+            <a:ext cx="5669280" cy="1828800"/>
           </a:xfrm>
           <a:prstGeom prst="rect">
             <a:avLst/>
@@ -3895,212 +6046,43 @@
           <a:p>
             <a:pPr>
               <a:spcAft>
-                <a:spcPts val="1400"/>
+                <a:spcPts val="1200"/>
               </a:spcAft>
-              <a:defRPr sz="1500">
-                <a:solidFill>
-                  <a:srgbClr val="334155"/>
+              <a:defRPr sz="1800" b="1">
+                <a:solidFill>
+                  <a:srgbClr val="FFFFFF"/>
                 </a:solidFill>
               </a:defRPr>
             </a:pPr>
             <a:r>
-              <a:t>• 1. Site Survey &amp; Audit Struktur Kelistrikan</a:t>
+              <a:t>SIAP BERTRANSISI KE ENERGI HIJAU?</a:t>
             </a:r>
           </a:p>
           <a:p>
             <a:pPr>
               <a:spcAft>
-                <a:spcPts val="1400"/>
+                <a:spcPts val="1600"/>
               </a:spcAft>
-              <a:defRPr sz="1500">
-                <a:solidFill>
-                  <a:srgbClr val="334155"/>
+              <a:defRPr sz="1300">
+                <a:solidFill>
+                  <a:srgbClr val="CBD5E1"/>
                 </a:solidFill>
               </a:defRPr>
             </a:pPr>
             <a:r>
-              <a:t>• 2. Detailed Engineering Design (DED) &amp; Simulasi Final</a:t>
+              <a:t>Dapatkan konsultasi teknis, audit profil beban, dan proposal penawaran komprehensif secara gratis.</a:t>
             </a:r>
           </a:p>
           <a:p>
             <a:pPr>
-              <a:spcAft>
-                <a:spcPts val="1400"/>
-              </a:spcAft>
-              <a:defRPr sz="1500">
-                <a:solidFill>
-                  <a:srgbClr val="334155"/>
+              <a:defRPr sz="1200" b="1">
+                <a:solidFill>
+                  <a:srgbClr val="EA580C"/>
                 </a:solidFill>
               </a:defRPr>
             </a:pPr>
             <a:r>
-              <a:t>• 3. Perizinan PLN (Parallel Operation &amp; SLO)</a:t>
-            </a:r>
-          </a:p>
-          <a:p>
-            <a:pPr>
-              <a:spcAft>
-                <a:spcPts val="1400"/>
-              </a:spcAft>
-              <a:defRPr sz="1500">
-                <a:solidFill>
-                  <a:srgbClr val="334155"/>
-                </a:solidFill>
-              </a:defRPr>
-            </a:pPr>
-            <a:r>
-              <a:t>• 4. Pengadaan, Instalasi, &amp; Komisioning Sistem</a:t>
-            </a:r>
-          </a:p>
-          <a:p>
-            <a:pPr>
-              <a:spcAft>
-                <a:spcPts val="1400"/>
-              </a:spcAft>
-              <a:defRPr sz="1500">
-                <a:solidFill>
-                  <a:srgbClr val="334155"/>
-                </a:solidFill>
-              </a:defRPr>
-            </a:pPr>
-            <a:r>
-              <a:t>• 5. Handover, Monitoring, &amp; Layanan Pemeliharaan</a:t>
-            </a:r>
-          </a:p>
-        </p:txBody>
-      </p:sp>
-    </p:spTree>
-  </p:cSld>
-  <p:clrMapOvr>
-    <a:masterClrMapping/>
-  </p:clrMapOvr>
-</p:sld>
-</file>
-
-<file path=ppt/slides/slide8.xml><?xml version="1.0" encoding="utf-8"?>
-<p:sld xmlns:a="http://schemas.openxmlformats.org/drawingml/2006/main" xmlns:p="http://schemas.openxmlformats.org/presentationml/2006/main" xmlns:r="http://schemas.openxmlformats.org/officeDocument/2006/relationships">
-  <p:cSld>
-    <p:spTree>
-      <p:nvGrpSpPr>
-        <p:cNvPr id="1" name=""/>
-        <p:cNvGrpSpPr/>
-        <p:nvPr/>
-      </p:nvGrpSpPr>
-      <p:grpSpPr/>
-      <p:sp>
-        <p:nvSpPr>
-          <p:cNvPr id="2" name="TextBox 1"/>
-          <p:cNvSpPr txBox="1"/>
-          <p:nvPr/>
-        </p:nvSpPr>
-        <p:spPr>
-          <a:xfrm>
-            <a:off x="731520" y="548640"/>
-            <a:ext cx="7680960" cy="731520"/>
-          </a:xfrm>
-          <a:prstGeom prst="rect">
-            <a:avLst/>
-          </a:prstGeom>
-          <a:noFill/>
-        </p:spPr>
-        <p:txBody>
-          <a:bodyPr wrap="square">
-            <a:spAutoFit/>
-          </a:bodyPr>
-          <a:lstStyle/>
-          <a:p>
-            <a:pPr>
-              <a:defRPr sz="2200" b="1">
-                <a:solidFill>
-                  <a:srgbClr val="0F172A"/>
-                </a:solidFill>
-              </a:defRPr>
-            </a:pPr>
-            <a:r>
-              <a:t>LANGKAH SELANJUTNYA &amp; DISKUSI</a:t>
-            </a:r>
-          </a:p>
-        </p:txBody>
-      </p:sp>
-      <p:sp>
-        <p:nvSpPr>
-          <p:cNvPr id="3" name="TextBox 2"/>
-          <p:cNvSpPr txBox="1"/>
-          <p:nvPr/>
-        </p:nvSpPr>
-        <p:spPr>
-          <a:xfrm>
-            <a:off x="731520" y="1371600"/>
-            <a:ext cx="7680960" cy="3200400"/>
-          </a:xfrm>
-          <a:prstGeom prst="rect">
-            <a:avLst/>
-          </a:prstGeom>
-          <a:noFill/>
-        </p:spPr>
-        <p:txBody>
-          <a:bodyPr wrap="square">
-            <a:spAutoFit/>
-          </a:bodyPr>
-          <a:lstStyle/>
-          <a:p>
-            <a:pPr>
-              <a:spcAft>
-                <a:spcPts val="1400"/>
-              </a:spcAft>
-              <a:defRPr sz="1500">
-                <a:solidFill>
-                  <a:srgbClr val="334155"/>
-                </a:solidFill>
-              </a:defRPr>
-            </a:pPr>
-            <a:r>
-              <a:t>• Jadwalkan survei lokasi teknis dan audit profil beban gratis</a:t>
-            </a:r>
-          </a:p>
-          <a:p>
-            <a:pPr>
-              <a:spcAft>
-                <a:spcPts val="1400"/>
-              </a:spcAft>
-              <a:defRPr sz="1500">
-                <a:solidFill>
-                  <a:srgbClr val="334155"/>
-                </a:solidFill>
-              </a:defRPr>
-            </a:pPr>
-            <a:r>
-              <a:t>• Dapatkan proposal teknis &amp; tekno-ekonomi terperinci untuk perusahaan Anda</a:t>
-            </a:r>
-          </a:p>
-          <a:p>
-            <a:pPr>
-              <a:spcAft>
-                <a:spcPts val="1400"/>
-              </a:spcAft>
-              <a:defRPr sz="1500">
-                <a:solidFill>
-                  <a:srgbClr val="334155"/>
-                </a:solidFill>
-              </a:defRPr>
-            </a:pPr>
-            <a:r>
-              <a:t>• Q &amp; A / Diskusi Teknis &amp; Finansial</a:t>
-            </a:r>
-          </a:p>
-          <a:p>
-            <a:pPr>
-              <a:spcAft>
-                <a:spcPts val="1400"/>
-              </a:spcAft>
-              <a:defRPr sz="1500">
-                <a:solidFill>
-                  <a:srgbClr val="334155"/>
-                </a:solidFill>
-              </a:defRPr>
-            </a:pPr>
-            <a:r>
-              <a:t>• Kontak &amp; Konsultasi Lanjut</a:t>
+              <a:t>👉 Hubungi Tim Konsultan Energi Kami untuk Penjadwalan Survey Lokasi</a:t>
             </a:r>
           </a:p>
         </p:txBody>

</xml_diff>